<commit_message>
Refresh 1-slider to RVAP-branded current-status deck; gitignore root working copy
- Replace the published site/assets 1-slider (served by the Download button
  on site/delivery.html) with a rebuilt single-slide deck that reflects the
  current status: RVAS naming, repo microsoft/frontier-fabric-governance-rvas,
  live Pages site + delivery Builder, and the genericized reference model.
- Apply the RVAP brand identity: Deep Navy / RVAP Blue / Charcoal palette,
  Build/Innovate/Scale pillar colors mapped across the 5-step journey,
  Aptos Display/Aptos fonts, RVAP logo, and the 'Build. Innovate. Scale
  real value.' tagline.
- Git-ignore the editable root working copy
  (/Agentic-Governance-Blueprint-for-Fabric-1-slider.pptx); the published
  copy in site/assets/ remains tracked so the live download stays current.

Co-authored-by: Copilot <223556219+Copilot@users.noreply.github.com>
</commit_message>
<xml_diff>
--- a/site/assets/Agentic-Governance-Blueprint-for-Fabric-1-slider.pptx
+++ b/site/assets/Agentic-Governance-Blueprint-for-Fabric-1-slider.pptx
@@ -877,14 +877,58 @@
       </p:grpSpPr>
       <p:sp>
         <p:nvSpPr>
-          <p:cNvPr id="2" name="Text 0"/>
-          <p:cNvSpPr/>
-          <p:nvPr/>
-        </p:nvSpPr>
-        <p:spPr>
-          <a:xfrm>
-            <a:off x="274320" y="128016"/>
-            <a:ext cx="9784080" cy="640080"/>
+          <p:cNvPr id="2" name="Shape 0"/>
+          <p:cNvSpPr/>
+          <p:nvPr/>
+        </p:nvSpPr>
+        <p:spPr>
+          <a:xfrm>
+            <a:off x="0" y="0"/>
+            <a:ext cx="12188952" cy="82296"/>
+          </a:xfrm>
+          <a:prstGeom prst="rect">
+            <a:avLst/>
+          </a:prstGeom>
+          <a:solidFill>
+            <a:srgbClr val="032254"/>
+          </a:solidFill>
+          <a:ln/>
+        </p:spPr>
+      </p:sp>
+      <p:pic>
+        <p:nvPicPr>
+          <p:cNvPr id="3" name="Image 0" descr="assets/logo-cropped.png">    </p:cNvPr>
+          <p:cNvPicPr>
+            <a:picLocks noChangeAspect="1"/>
+          </p:cNvPicPr>
+          <p:nvPr/>
+        </p:nvPicPr>
+        <p:blipFill>
+          <a:blip r:embed="rId1"/>
+          <a:stretch>
+            <a:fillRect/>
+          </a:stretch>
+        </p:blipFill>
+        <p:spPr>
+          <a:xfrm>
+            <a:off x="274320" y="246888"/>
+            <a:ext cx="1645920" cy="510235"/>
+          </a:xfrm>
+          <a:prstGeom prst="rect">
+            <a:avLst/>
+          </a:prstGeom>
+        </p:spPr>
+      </p:pic>
+      <p:sp>
+        <p:nvSpPr>
+          <p:cNvPr id="4" name="Text 1"/>
+          <p:cNvSpPr/>
+          <p:nvPr/>
+        </p:nvSpPr>
+        <p:spPr>
+          <a:xfrm>
+            <a:off x="2084832" y="164592"/>
+            <a:ext cx="7086600" cy="658368"/>
           </a:xfrm>
           <a:prstGeom prst="rect">
             <a:avLst/>
@@ -900,30 +944,30 @@
               <a:buNone/>
             </a:pPr>
             <a:r>
-              <a:rPr lang="en-US" sz="3000" b="1" dirty="0">
-                <a:solidFill>
-                  <a:srgbClr val="1F3864"/>
-                </a:solidFill>
-                <a:latin typeface="Segoe UI" pitchFamily="34" charset="0"/>
-                <a:ea typeface="Segoe UI" pitchFamily="34" charset="-122"/>
-                <a:cs typeface="Segoe UI" pitchFamily="34" charset="-120"/>
+              <a:rPr lang="en-US" sz="2500" b="1" dirty="0">
+                <a:solidFill>
+                  <a:srgbClr val="032254"/>
+                </a:solidFill>
+                <a:latin typeface="Aptos Display" pitchFamily="34" charset="0"/>
+                <a:ea typeface="Aptos Display" pitchFamily="34" charset="-122"/>
+                <a:cs typeface="Aptos Display" pitchFamily="34" charset="-120"/>
               </a:rPr>
               <a:t>Agentic Governance Blueprint for Fabric</a:t>
             </a:r>
-            <a:endParaRPr lang="en-US" sz="3000" dirty="0"/>
+            <a:endParaRPr lang="en-US" sz="2500" dirty="0"/>
           </a:p>
         </p:txBody>
       </p:sp>
       <p:sp>
         <p:nvSpPr>
-          <p:cNvPr id="3" name="Text 1"/>
-          <p:cNvSpPr/>
-          <p:nvPr/>
-        </p:nvSpPr>
-        <p:spPr>
-          <a:xfrm>
-            <a:off x="10104120" y="73152"/>
-            <a:ext cx="1828800" cy="749808"/>
+          <p:cNvPr id="5" name="Text 2"/>
+          <p:cNvSpPr/>
+          <p:nvPr/>
+        </p:nvSpPr>
+        <p:spPr>
+          <a:xfrm>
+            <a:off x="9281160" y="201168"/>
+            <a:ext cx="2651760" cy="566928"/>
           </a:xfrm>
           <a:prstGeom prst="rect">
             <a:avLst/>
@@ -935,34 +979,80 @@
           <a:bodyPr wrap="square" lIns="0" tIns="0" rIns="0" bIns="0" rtlCol="0" anchor="ctr"/>
           <a:lstStyle/>
           <a:p>
-            <a:pPr algn="ctr" indent="0" marL="0">
-              <a:buNone/>
-            </a:pPr>
-            <a:r>
-              <a:rPr lang="en-US" sz="4600" b="1" dirty="0">
-                <a:solidFill>
-                  <a:srgbClr val="9DB8E0"/>
-                </a:solidFill>
-                <a:latin typeface="Segoe UI" pitchFamily="34" charset="0"/>
-                <a:ea typeface="Segoe UI" pitchFamily="34" charset="-122"/>
-                <a:cs typeface="Segoe UI" pitchFamily="34" charset="-120"/>
-              </a:rPr>
-              <a:t>TBD</a:t>
-            </a:r>
-            <a:endParaRPr lang="en-US" sz="4600" dirty="0"/>
+            <a:pPr algn="r" indent="0" marL="0">
+              <a:lnSpc>
+                <a:spcPct val="100000"/>
+              </a:lnSpc>
+              <a:buNone/>
+            </a:pPr>
+            <a:r>
+              <a:rPr lang="en-US" sz="1600" b="1" dirty="0">
+                <a:solidFill>
+                  <a:srgbClr val="1A77E3"/>
+                </a:solidFill>
+                <a:latin typeface="Aptos Display" pitchFamily="34" charset="0"/>
+                <a:ea typeface="Aptos Display" pitchFamily="34" charset="-122"/>
+                <a:cs typeface="Aptos Display" pitchFamily="34" charset="-120"/>
+              </a:rPr>
+              <a:t>RVAS</a:t>
+            </a:r>
+            <a:endParaRPr lang="en-US" sz="1600" dirty="0"/>
+          </a:p>
+          <a:p>
+            <a:pPr algn="r" indent="0" marL="0">
+              <a:lnSpc>
+                <a:spcPct val="100000"/>
+              </a:lnSpc>
+              <a:buNone/>
+            </a:pPr>
+            <a:r>
+              <a:rPr lang="en-US" sz="750" dirty="0">
+                <a:solidFill>
+                  <a:srgbClr val="6B7280"/>
+                </a:solidFill>
+                <a:latin typeface="Aptos" pitchFamily="34" charset="0"/>
+                <a:ea typeface="Aptos" pitchFamily="34" charset="-122"/>
+                <a:cs typeface="Aptos" pitchFamily="34" charset="-120"/>
+              </a:rPr>
+              <a:t>Real Value Acceleration Solution</a:t>
+            </a:r>
+            <a:endParaRPr lang="en-US" sz="1600" dirty="0"/>
           </a:p>
         </p:txBody>
       </p:sp>
       <p:sp>
         <p:nvSpPr>
-          <p:cNvPr id="4" name="Shape 2"/>
-          <p:cNvSpPr/>
-          <p:nvPr/>
-        </p:nvSpPr>
-        <p:spPr>
-          <a:xfrm>
-            <a:off x="256032" y="841248"/>
-            <a:ext cx="5705856" cy="1188720"/>
+          <p:cNvPr id="6" name="Shape 3"/>
+          <p:cNvSpPr/>
+          <p:nvPr/>
+        </p:nvSpPr>
+        <p:spPr>
+          <a:xfrm>
+            <a:off x="0" y="914400"/>
+            <a:ext cx="12188952" cy="0"/>
+          </a:xfrm>
+          <a:prstGeom prst="line">
+            <a:avLst/>
+          </a:prstGeom>
+          <a:noFill/>
+          <a:ln w="12700">
+            <a:solidFill>
+              <a:srgbClr val="E3E6ED"/>
+            </a:solidFill>
+            <a:prstDash val="solid"/>
+          </a:ln>
+        </p:spPr>
+      </p:sp>
+      <p:sp>
+        <p:nvSpPr>
+          <p:cNvPr id="7" name="Shape 4"/>
+          <p:cNvSpPr/>
+          <p:nvPr/>
+        </p:nvSpPr>
+        <p:spPr>
+          <a:xfrm>
+            <a:off x="256032" y="1005840"/>
+            <a:ext cx="5705856" cy="1097280"/>
           </a:xfrm>
           <a:prstGeom prst="rect">
             <a:avLst/>
@@ -972,7 +1062,7 @@
           </a:solidFill>
           <a:ln w="12700">
             <a:solidFill>
-              <a:srgbClr val="BFBFBF"/>
+              <a:srgbClr val="E3E6ED"/>
             </a:solidFill>
             <a:prstDash val="solid"/>
           </a:ln>
@@ -980,14 +1070,34 @@
       </p:sp>
       <p:sp>
         <p:nvSpPr>
-          <p:cNvPr id="5" name="Shape 3"/>
-          <p:cNvSpPr/>
-          <p:nvPr/>
-        </p:nvSpPr>
-        <p:spPr>
-          <a:xfrm>
-            <a:off x="6217920" y="841248"/>
-            <a:ext cx="5715000" cy="1188720"/>
+          <p:cNvPr id="8" name="Shape 5"/>
+          <p:cNvSpPr/>
+          <p:nvPr/>
+        </p:nvSpPr>
+        <p:spPr>
+          <a:xfrm>
+            <a:off x="256032" y="1005840"/>
+            <a:ext cx="5705856" cy="50292"/>
+          </a:xfrm>
+          <a:prstGeom prst="rect">
+            <a:avLst/>
+          </a:prstGeom>
+          <a:solidFill>
+            <a:srgbClr val="1A77E3"/>
+          </a:solidFill>
+          <a:ln/>
+        </p:spPr>
+      </p:sp>
+      <p:sp>
+        <p:nvSpPr>
+          <p:cNvPr id="9" name="Shape 6"/>
+          <p:cNvSpPr/>
+          <p:nvPr/>
+        </p:nvSpPr>
+        <p:spPr>
+          <a:xfrm>
+            <a:off x="6217920" y="1005840"/>
+            <a:ext cx="5715000" cy="1097280"/>
           </a:xfrm>
           <a:prstGeom prst="rect">
             <a:avLst/>
@@ -997,7 +1107,7 @@
           </a:solidFill>
           <a:ln w="12700">
             <a:solidFill>
-              <a:srgbClr val="BFBFBF"/>
+              <a:srgbClr val="E3E6ED"/>
             </a:solidFill>
             <a:prstDash val="solid"/>
           </a:ln>
@@ -1005,13 +1115,33 @@
       </p:sp>
       <p:sp>
         <p:nvSpPr>
-          <p:cNvPr id="6" name="Text 4"/>
-          <p:cNvSpPr/>
-          <p:nvPr/>
-        </p:nvSpPr>
-        <p:spPr>
-          <a:xfrm>
-            <a:off x="365760" y="886968"/>
+          <p:cNvPr id="10" name="Shape 7"/>
+          <p:cNvSpPr/>
+          <p:nvPr/>
+        </p:nvSpPr>
+        <p:spPr>
+          <a:xfrm>
+            <a:off x="6217920" y="1005840"/>
+            <a:ext cx="5715000" cy="50292"/>
+          </a:xfrm>
+          <a:prstGeom prst="rect">
+            <a:avLst/>
+          </a:prstGeom>
+          <a:solidFill>
+            <a:srgbClr val="1A77E3"/>
+          </a:solidFill>
+          <a:ln/>
+        </p:spPr>
+      </p:sp>
+      <p:sp>
+        <p:nvSpPr>
+          <p:cNvPr id="11" name="Text 8"/>
+          <p:cNvSpPr/>
+          <p:nvPr/>
+        </p:nvSpPr>
+        <p:spPr>
+          <a:xfrm>
+            <a:off x="365760" y="1088136"/>
             <a:ext cx="5486400" cy="219456"/>
           </a:xfrm>
           <a:prstGeom prst="rect">
@@ -1030,13 +1160,13 @@
             <a:r>
               <a:rPr lang="en-US" sz="1150" b="1" dirty="0">
                 <a:solidFill>
-                  <a:srgbClr val="1F4E79"/>
-                </a:solidFill>
-                <a:latin typeface="Segoe UI" pitchFamily="34" charset="0"/>
-                <a:ea typeface="Segoe UI" pitchFamily="34" charset="-122"/>
-                <a:cs typeface="Segoe UI" pitchFamily="34" charset="-120"/>
-              </a:rPr>
-              <a:t>Business Scenario:</a:t>
+                  <a:srgbClr val="032254"/>
+                </a:solidFill>
+                <a:latin typeface="Aptos Display" pitchFamily="34" charset="0"/>
+                <a:ea typeface="Aptos Display" pitchFamily="34" charset="-122"/>
+                <a:cs typeface="Aptos Display" pitchFamily="34" charset="-120"/>
+              </a:rPr>
+              <a:t>Business scenario</a:t>
             </a:r>
             <a:endParaRPr lang="en-US" sz="1150" dirty="0"/>
           </a:p>
@@ -1044,14 +1174,14 @@
       </p:sp>
       <p:sp>
         <p:nvSpPr>
-          <p:cNvPr id="7" name="Text 5"/>
-          <p:cNvSpPr/>
-          <p:nvPr/>
-        </p:nvSpPr>
-        <p:spPr>
-          <a:xfrm>
-            <a:off x="365760" y="1115568"/>
-            <a:ext cx="5504688" cy="859536"/>
+          <p:cNvPr id="12" name="Text 9"/>
+          <p:cNvSpPr/>
+          <p:nvPr/>
+        </p:nvSpPr>
+        <p:spPr>
+          <a:xfrm>
+            <a:off x="365760" y="1316736"/>
+            <a:ext cx="5504688" cy="713232"/>
           </a:xfrm>
           <a:prstGeom prst="rect">
             <a:avLst/>
@@ -1072,11 +1202,11 @@
             <a:r>
               <a:rPr lang="en-US" sz="1050" dirty="0">
                 <a:solidFill>
-                  <a:srgbClr val="404040"/>
-                </a:solidFill>
-                <a:latin typeface="Segoe UI" pitchFamily="34" charset="0"/>
-                <a:ea typeface="Segoe UI" pitchFamily="34" charset="-122"/>
-                <a:cs typeface="Segoe UI" pitchFamily="34" charset="-120"/>
+                  <a:srgbClr val="47494E"/>
+                </a:solidFill>
+                <a:latin typeface="Aptos" pitchFamily="34" charset="0"/>
+                <a:ea typeface="Aptos" pitchFamily="34" charset="-122"/>
+                <a:cs typeface="Aptos" pitchFamily="34" charset="-120"/>
               </a:rPr>
               <a:t>An agent-assisted governance framework that helps teams deploy Fabric the "right way" faster — codifying standards and producing repeatable templates, checks, and guidance using Fabric Skills and GitHub Copilot powered by skills-for-fabric Agents.</a:t>
             </a:r>
@@ -1086,13 +1216,13 @@
       </p:sp>
       <p:sp>
         <p:nvSpPr>
-          <p:cNvPr id="8" name="Text 6"/>
-          <p:cNvSpPr/>
-          <p:nvPr/>
-        </p:nvSpPr>
-        <p:spPr>
-          <a:xfrm>
-            <a:off x="6327648" y="886968"/>
+          <p:cNvPr id="13" name="Text 10"/>
+          <p:cNvSpPr/>
+          <p:nvPr/>
+        </p:nvSpPr>
+        <p:spPr>
+          <a:xfrm>
+            <a:off x="6327648" y="1088136"/>
             <a:ext cx="5486400" cy="219456"/>
           </a:xfrm>
           <a:prstGeom prst="rect">
@@ -1111,13 +1241,13 @@
             <a:r>
               <a:rPr lang="en-US" sz="1150" b="1" dirty="0">
                 <a:solidFill>
-                  <a:srgbClr val="1F4E79"/>
-                </a:solidFill>
-                <a:latin typeface="Segoe UI" pitchFamily="34" charset="0"/>
-                <a:ea typeface="Segoe UI" pitchFamily="34" charset="-122"/>
-                <a:cs typeface="Segoe UI" pitchFamily="34" charset="-120"/>
-              </a:rPr>
-              <a:t>Technical Scenario:</a:t>
+                  <a:srgbClr val="032254"/>
+                </a:solidFill>
+                <a:latin typeface="Aptos Display" pitchFamily="34" charset="0"/>
+                <a:ea typeface="Aptos Display" pitchFamily="34" charset="-122"/>
+                <a:cs typeface="Aptos Display" pitchFamily="34" charset="-120"/>
+              </a:rPr>
+              <a:t>Technical scenario</a:t>
             </a:r>
             <a:endParaRPr lang="en-US" sz="1150" dirty="0"/>
           </a:p>
@@ -1125,14 +1255,14 @@
       </p:sp>
       <p:sp>
         <p:nvSpPr>
-          <p:cNvPr id="9" name="Text 7"/>
-          <p:cNvSpPr/>
-          <p:nvPr/>
-        </p:nvSpPr>
-        <p:spPr>
-          <a:xfrm>
-            <a:off x="6327648" y="1115568"/>
-            <a:ext cx="5495544" cy="859536"/>
+          <p:cNvPr id="14" name="Text 11"/>
+          <p:cNvSpPr/>
+          <p:nvPr/>
+        </p:nvSpPr>
+        <p:spPr>
+          <a:xfrm>
+            <a:off x="6327648" y="1316736"/>
+            <a:ext cx="5495544" cy="713232"/>
           </a:xfrm>
           <a:prstGeom prst="rect">
             <a:avLst/>
@@ -1153,11 +1283,11 @@
             <a:r>
               <a:rPr lang="en-US" sz="1050" dirty="0">
                 <a:solidFill>
-                  <a:srgbClr val="404040"/>
-                </a:solidFill>
-                <a:latin typeface="Segoe UI" pitchFamily="34" charset="0"/>
-                <a:ea typeface="Segoe UI" pitchFamily="34" charset="-122"/>
-                <a:cs typeface="Segoe UI" pitchFamily="34" charset="-120"/>
+                  <a:srgbClr val="47494E"/>
+                </a:solidFill>
+                <a:latin typeface="Aptos" pitchFamily="34" charset="0"/>
+                <a:ea typeface="Aptos" pitchFamily="34" charset="-122"/>
+                <a:cs typeface="Aptos" pitchFamily="34" charset="-120"/>
               </a:rPr>
               <a:t>Treat the Fabric tenant as </a:t>
             </a:r>
@@ -1170,11 +1300,11 @@
             <a:r>
               <a:rPr lang="en-US" sz="1050" b="1" dirty="0">
                 <a:solidFill>
-                  <a:srgbClr val="404040"/>
-                </a:solidFill>
-                <a:latin typeface="Segoe UI" pitchFamily="34" charset="0"/>
-                <a:ea typeface="Segoe UI" pitchFamily="34" charset="-122"/>
-                <a:cs typeface="Segoe UI" pitchFamily="34" charset="-120"/>
+                  <a:srgbClr val="032254"/>
+                </a:solidFill>
+                <a:latin typeface="Aptos" pitchFamily="34" charset="0"/>
+                <a:ea typeface="Aptos" pitchFamily="34" charset="-122"/>
+                <a:cs typeface="Aptos" pitchFamily="34" charset="-120"/>
               </a:rPr>
               <a:t>declarative infrastructure</a:t>
             </a:r>
@@ -1187,11 +1317,11 @@
             <a:r>
               <a:rPr lang="en-US" sz="1050" dirty="0">
                 <a:solidFill>
-                  <a:srgbClr val="404040"/>
-                </a:solidFill>
-                <a:latin typeface="Segoe UI" pitchFamily="34" charset="0"/>
-                <a:ea typeface="Segoe UI" pitchFamily="34" charset="-122"/>
-                <a:cs typeface="Segoe UI" pitchFamily="34" charset="-120"/>
+                  <a:srgbClr val="47494E"/>
+                </a:solidFill>
+                <a:latin typeface="Aptos" pitchFamily="34" charset="0"/>
+                <a:ea typeface="Aptos" pitchFamily="34" charset="-122"/>
+                <a:cs typeface="Aptos" pitchFamily="34" charset="-120"/>
               </a:rPr>
               <a:t>: every workspace, item, role, label, agent, and promotion is a YAML manifest in Git — reviewed via Pull Request and applied by a service principal with </a:t>
             </a:r>
@@ -1204,11 +1334,11 @@
             <a:r>
               <a:rPr lang="en-US" sz="1050" b="1" dirty="0">
                 <a:solidFill>
-                  <a:srgbClr val="404040"/>
-                </a:solidFill>
-                <a:latin typeface="Segoe UI" pitchFamily="34" charset="0"/>
-                <a:ea typeface="Segoe UI" pitchFamily="34" charset="-122"/>
-                <a:cs typeface="Segoe UI" pitchFamily="34" charset="-120"/>
+                  <a:srgbClr val="032254"/>
+                </a:solidFill>
+                <a:latin typeface="Aptos" pitchFamily="34" charset="0"/>
+                <a:ea typeface="Aptos" pitchFamily="34" charset="-122"/>
+                <a:cs typeface="Aptos" pitchFamily="34" charset="-120"/>
               </a:rPr>
               <a:t>no long-lived secrets</a:t>
             </a:r>
@@ -1221,11 +1351,11 @@
             <a:r>
               <a:rPr lang="en-US" sz="1050" dirty="0">
                 <a:solidFill>
-                  <a:srgbClr val="404040"/>
-                </a:solidFill>
-                <a:latin typeface="Segoe UI" pitchFamily="34" charset="0"/>
-                <a:ea typeface="Segoe UI" pitchFamily="34" charset="-122"/>
-                <a:cs typeface="Segoe UI" pitchFamily="34" charset="-120"/>
+                  <a:srgbClr val="47494E"/>
+                </a:solidFill>
+                <a:latin typeface="Aptos" pitchFamily="34" charset="0"/>
+                <a:ea typeface="Aptos" pitchFamily="34" charset="-122"/>
+                <a:cs typeface="Aptos" pitchFamily="34" charset="-120"/>
               </a:rPr>
               <a:t>. Fabric MCP servers, Skills for Fabric, and GitHub Copilot accelerate authoring and review without ever bypassing the gate.</a:t>
             </a:r>
@@ -1235,14 +1365,14 @@
       </p:sp>
       <p:sp>
         <p:nvSpPr>
-          <p:cNvPr id="10" name="Shape 8"/>
-          <p:cNvSpPr/>
-          <p:nvPr/>
-        </p:nvSpPr>
-        <p:spPr>
-          <a:xfrm>
-            <a:off x="256032" y="2103120"/>
-            <a:ext cx="5705856" cy="1060704"/>
+          <p:cNvPr id="15" name="Shape 12"/>
+          <p:cNvSpPr/>
+          <p:nvPr/>
+        </p:nvSpPr>
+        <p:spPr>
+          <a:xfrm>
+            <a:off x="256032" y="2194560"/>
+            <a:ext cx="5705856" cy="1042416"/>
           </a:xfrm>
           <a:prstGeom prst="rect">
             <a:avLst/>
@@ -1252,7 +1382,7 @@
           </a:solidFill>
           <a:ln w="12700">
             <a:solidFill>
-              <a:srgbClr val="BFBFBF"/>
+              <a:srgbClr val="E3E6ED"/>
             </a:solidFill>
             <a:prstDash val="solid"/>
           </a:ln>
@@ -1260,14 +1390,34 @@
       </p:sp>
       <p:sp>
         <p:nvSpPr>
-          <p:cNvPr id="11" name="Shape 9"/>
-          <p:cNvSpPr/>
-          <p:nvPr/>
-        </p:nvSpPr>
-        <p:spPr>
-          <a:xfrm>
-            <a:off x="6217920" y="2103120"/>
-            <a:ext cx="2761488" cy="1060704"/>
+          <p:cNvPr id="16" name="Shape 13"/>
+          <p:cNvSpPr/>
+          <p:nvPr/>
+        </p:nvSpPr>
+        <p:spPr>
+          <a:xfrm>
+            <a:off x="256032" y="2194560"/>
+            <a:ext cx="5705856" cy="50292"/>
+          </a:xfrm>
+          <a:prstGeom prst="rect">
+            <a:avLst/>
+          </a:prstGeom>
+          <a:solidFill>
+            <a:srgbClr val="1A77E3"/>
+          </a:solidFill>
+          <a:ln/>
+        </p:spPr>
+      </p:sp>
+      <p:sp>
+        <p:nvSpPr>
+          <p:cNvPr id="17" name="Shape 14"/>
+          <p:cNvSpPr/>
+          <p:nvPr/>
+        </p:nvSpPr>
+        <p:spPr>
+          <a:xfrm>
+            <a:off x="6217920" y="2194560"/>
+            <a:ext cx="2761488" cy="1042416"/>
           </a:xfrm>
           <a:prstGeom prst="rect">
             <a:avLst/>
@@ -1277,7 +1427,7 @@
           </a:solidFill>
           <a:ln w="12700">
             <a:solidFill>
-              <a:srgbClr val="BFBFBF"/>
+              <a:srgbClr val="E3E6ED"/>
             </a:solidFill>
             <a:prstDash val="solid"/>
           </a:ln>
@@ -1285,14 +1435,34 @@
       </p:sp>
       <p:sp>
         <p:nvSpPr>
-          <p:cNvPr id="12" name="Shape 10"/>
-          <p:cNvSpPr/>
-          <p:nvPr/>
-        </p:nvSpPr>
-        <p:spPr>
-          <a:xfrm>
-            <a:off x="9107424" y="2103120"/>
-            <a:ext cx="2825496" cy="1060704"/>
+          <p:cNvPr id="18" name="Shape 15"/>
+          <p:cNvSpPr/>
+          <p:nvPr/>
+        </p:nvSpPr>
+        <p:spPr>
+          <a:xfrm>
+            <a:off x="6217920" y="2194560"/>
+            <a:ext cx="2761488" cy="50292"/>
+          </a:xfrm>
+          <a:prstGeom prst="rect">
+            <a:avLst/>
+          </a:prstGeom>
+          <a:solidFill>
+            <a:srgbClr val="1A77E3"/>
+          </a:solidFill>
+          <a:ln/>
+        </p:spPr>
+      </p:sp>
+      <p:sp>
+        <p:nvSpPr>
+          <p:cNvPr id="19" name="Shape 16"/>
+          <p:cNvSpPr/>
+          <p:nvPr/>
+        </p:nvSpPr>
+        <p:spPr>
+          <a:xfrm>
+            <a:off x="9107424" y="2194560"/>
+            <a:ext cx="2825496" cy="1042416"/>
           </a:xfrm>
           <a:prstGeom prst="rect">
             <a:avLst/>
@@ -1302,7 +1472,7 @@
           </a:solidFill>
           <a:ln w="12700">
             <a:solidFill>
-              <a:srgbClr val="BFBFBF"/>
+              <a:srgbClr val="E3E6ED"/>
             </a:solidFill>
             <a:prstDash val="solid"/>
           </a:ln>
@@ -1310,13 +1480,33 @@
       </p:sp>
       <p:sp>
         <p:nvSpPr>
-          <p:cNvPr id="13" name="Text 11"/>
-          <p:cNvSpPr/>
-          <p:nvPr/>
-        </p:nvSpPr>
-        <p:spPr>
-          <a:xfrm>
-            <a:off x="365760" y="2148840"/>
+          <p:cNvPr id="20" name="Shape 17"/>
+          <p:cNvSpPr/>
+          <p:nvPr/>
+        </p:nvSpPr>
+        <p:spPr>
+          <a:xfrm>
+            <a:off x="9107424" y="2194560"/>
+            <a:ext cx="2825496" cy="50292"/>
+          </a:xfrm>
+          <a:prstGeom prst="rect">
+            <a:avLst/>
+          </a:prstGeom>
+          <a:solidFill>
+            <a:srgbClr val="1A77E3"/>
+          </a:solidFill>
+          <a:ln/>
+        </p:spPr>
+      </p:sp>
+      <p:sp>
+        <p:nvSpPr>
+          <p:cNvPr id="21" name="Text 18"/>
+          <p:cNvSpPr/>
+          <p:nvPr/>
+        </p:nvSpPr>
+        <p:spPr>
+          <a:xfrm>
+            <a:off x="365760" y="2276856"/>
             <a:ext cx="5486400" cy="201168"/>
           </a:xfrm>
           <a:prstGeom prst="rect">
@@ -1335,13 +1525,13 @@
             <a:r>
               <a:rPr lang="en-US" sz="1150" b="1" dirty="0">
                 <a:solidFill>
-                  <a:srgbClr val="1F4E79"/>
-                </a:solidFill>
-                <a:latin typeface="Segoe UI" pitchFamily="34" charset="0"/>
-                <a:ea typeface="Segoe UI" pitchFamily="34" charset="-122"/>
-                <a:cs typeface="Segoe UI" pitchFamily="34" charset="-120"/>
-              </a:rPr>
-              <a:t>Desired outcome:</a:t>
+                  <a:srgbClr val="032254"/>
+                </a:solidFill>
+                <a:latin typeface="Aptos Display" pitchFamily="34" charset="0"/>
+                <a:ea typeface="Aptos Display" pitchFamily="34" charset="-122"/>
+                <a:cs typeface="Aptos Display" pitchFamily="34" charset="-120"/>
+              </a:rPr>
+              <a:t>Desired outcome</a:t>
             </a:r>
             <a:endParaRPr lang="en-US" sz="1150" dirty="0"/>
           </a:p>
@@ -1349,14 +1539,14 @@
       </p:sp>
       <p:sp>
         <p:nvSpPr>
-          <p:cNvPr id="14" name="Text 12"/>
-          <p:cNvSpPr/>
-          <p:nvPr/>
-        </p:nvSpPr>
-        <p:spPr>
-          <a:xfrm>
-            <a:off x="475488" y="2395728"/>
-            <a:ext cx="5413248" cy="713232"/>
+          <p:cNvPr id="22" name="Text 19"/>
+          <p:cNvSpPr/>
+          <p:nvPr/>
+        </p:nvSpPr>
+        <p:spPr>
+          <a:xfrm>
+            <a:off x="493776" y="2505456"/>
+            <a:ext cx="5394960" cy="658368"/>
           </a:xfrm>
           <a:prstGeom prst="rect">
             <a:avLst/>
@@ -1378,11 +1568,11 @@
             <a:r>
               <a:rPr lang="en-US" sz="1000" dirty="0">
                 <a:solidFill>
-                  <a:srgbClr val="404040"/>
-                </a:solidFill>
-                <a:latin typeface="Segoe UI" pitchFamily="34" charset="0"/>
-                <a:ea typeface="Segoe UI" pitchFamily="34" charset="-122"/>
-                <a:cs typeface="Segoe UI" pitchFamily="34" charset="-120"/>
+                  <a:srgbClr val="47494E"/>
+                </a:solidFill>
+                <a:latin typeface="Aptos" pitchFamily="34" charset="0"/>
+                <a:ea typeface="Aptos" pitchFamily="34" charset="-122"/>
+                <a:cs typeface="Aptos" pitchFamily="34" charset="-120"/>
               </a:rPr>
               <a:t>Empty tenant → fully governed, PR-driven control plane in under 2 days</a:t>
             </a:r>
@@ -1399,11 +1589,11 @@
             <a:r>
               <a:rPr lang="en-US" sz="1000" dirty="0">
                 <a:solidFill>
-                  <a:srgbClr val="404040"/>
-                </a:solidFill>
-                <a:latin typeface="Segoe UI" pitchFamily="34" charset="0"/>
-                <a:ea typeface="Segoe UI" pitchFamily="34" charset="-122"/>
-                <a:cs typeface="Segoe UI" pitchFamily="34" charset="-120"/>
+                  <a:srgbClr val="47494E"/>
+                </a:solidFill>
+                <a:latin typeface="Aptos" pitchFamily="34" charset="0"/>
+                <a:ea typeface="Aptos" pitchFamily="34" charset="-122"/>
+                <a:cs typeface="Aptos" pitchFamily="34" charset="-120"/>
               </a:rPr>
               <a:t>Auditable, replayable artifacts — no ClickOps, no long-lived secrets</a:t>
             </a:r>
@@ -1420,11 +1610,11 @@
             <a:r>
               <a:rPr lang="en-US" sz="1000" dirty="0">
                 <a:solidFill>
-                  <a:srgbClr val="404040"/>
-                </a:solidFill>
-                <a:latin typeface="Segoe UI" pitchFamily="34" charset="0"/>
-                <a:ea typeface="Segoe UI" pitchFamily="34" charset="-122"/>
-                <a:cs typeface="Segoe UI" pitchFamily="34" charset="-120"/>
+                  <a:srgbClr val="47494E"/>
+                </a:solidFill>
+                <a:latin typeface="Aptos" pitchFamily="34" charset="0"/>
+                <a:ea typeface="Aptos" pitchFamily="34" charset="-122"/>
+                <a:cs typeface="Aptos" pitchFamily="34" charset="-120"/>
               </a:rPr>
               <a:t>Customer-owned repo + repeatable templates to continue immediately</a:t>
             </a:r>
@@ -1434,13 +1624,13 @@
       </p:sp>
       <p:sp>
         <p:nvSpPr>
-          <p:cNvPr id="15" name="Text 13"/>
-          <p:cNvSpPr/>
-          <p:nvPr/>
-        </p:nvSpPr>
-        <p:spPr>
-          <a:xfrm>
-            <a:off x="6327648" y="2148840"/>
+          <p:cNvPr id="23" name="Text 20"/>
+          <p:cNvSpPr/>
+          <p:nvPr/>
+        </p:nvSpPr>
+        <p:spPr>
+          <a:xfrm>
+            <a:off x="6327648" y="2276856"/>
             <a:ext cx="2560320" cy="201168"/>
           </a:xfrm>
           <a:prstGeom prst="rect">
@@ -1459,13 +1649,13 @@
             <a:r>
               <a:rPr lang="en-US" sz="1150" b="1" dirty="0">
                 <a:solidFill>
-                  <a:srgbClr val="1F4E79"/>
-                </a:solidFill>
-                <a:latin typeface="Segoe UI" pitchFamily="34" charset="0"/>
-                <a:ea typeface="Segoe UI" pitchFamily="34" charset="-122"/>
-                <a:cs typeface="Segoe UI" pitchFamily="34" charset="-120"/>
-              </a:rPr>
-              <a:t>Materials:</a:t>
+                  <a:srgbClr val="032254"/>
+                </a:solidFill>
+                <a:latin typeface="Aptos Display" pitchFamily="34" charset="0"/>
+                <a:ea typeface="Aptos Display" pitchFamily="34" charset="-122"/>
+                <a:cs typeface="Aptos Display" pitchFamily="34" charset="-120"/>
+              </a:rPr>
+              <a:t>Materials</a:t>
             </a:r>
             <a:endParaRPr lang="en-US" sz="1150" dirty="0"/>
           </a:p>
@@ -1473,14 +1663,14 @@
       </p:sp>
       <p:sp>
         <p:nvSpPr>
-          <p:cNvPr id="16" name="Text 14"/>
-          <p:cNvSpPr/>
-          <p:nvPr/>
-        </p:nvSpPr>
-        <p:spPr>
-          <a:xfrm>
-            <a:off x="6327648" y="2377440"/>
-            <a:ext cx="2578608" cy="731520"/>
+          <p:cNvPr id="24" name="Text 21"/>
+          <p:cNvSpPr/>
+          <p:nvPr/>
+        </p:nvSpPr>
+        <p:spPr>
+          <a:xfrm>
+            <a:off x="6327648" y="2496312"/>
+            <a:ext cx="2596896" cy="676656"/>
           </a:xfrm>
           <a:prstGeom prst="rect">
             <a:avLst/>
@@ -1494,45 +1684,18 @@
           <a:p>
             <a:pPr indent="0" marL="0">
               <a:spcAft>
-                <a:spcPts val="400"/>
-              </a:spcAft>
-              <a:buNone/>
-            </a:pPr>
-            <a:r>
-              <a:rPr lang="en-US" sz="950" u="sng" dirty="0">
-                <a:solidFill>
-                  <a:srgbClr val="2E74B5"/>
-                </a:solidFill>
-                <a:latin typeface="Segoe UI" pitchFamily="34" charset="0"/>
-                <a:ea typeface="Segoe UI" pitchFamily="34" charset="-122"/>
-                <a:cs typeface="Segoe UI" pitchFamily="34" charset="-120"/>
-                <a:hlinkClick r:id="rId1" invalidUrl="" action="" tgtFrame="" tooltip="" history="1" highlightClick="0" endSnd="0">
-                  <a:extLst>
-                    <a:ext uri="{A12FA001-AC4F-418D-AE19-62706E023703}">
-                      <ahyp:hlinkClr xmlns:ahyp="http://schemas.microsoft.com/office/drawing/2018/hyperlinkcolor" val="tx"/>
-                    </a:ext>
-                  </a:extLst>
-                </a:hlinkClick>
-              </a:rPr>
-              <a:t>Fabric Governance Hackathon</a:t>
-            </a:r>
-            <a:endParaRPr lang="en-US" sz="950" dirty="0"/>
-          </a:p>
-          <a:p>
-            <a:pPr indent="0" marL="0">
-              <a:spcAft>
-                <a:spcPts val="400"/>
-              </a:spcAft>
-              <a:buNone/>
-            </a:pPr>
-            <a:r>
-              <a:rPr lang="en-US" sz="950" u="sng" dirty="0">
-                <a:solidFill>
-                  <a:srgbClr val="2E74B5"/>
-                </a:solidFill>
-                <a:latin typeface="Segoe UI" pitchFamily="34" charset="0"/>
-                <a:ea typeface="Segoe UI" pitchFamily="34" charset="-122"/>
-                <a:cs typeface="Segoe UI" pitchFamily="34" charset="-120"/>
+                <a:spcPts val="350"/>
+              </a:spcAft>
+              <a:buNone/>
+            </a:pPr>
+            <a:r>
+              <a:rPr lang="en-US" sz="930" u="sng" dirty="0">
+                <a:solidFill>
+                  <a:srgbClr val="1A77E3"/>
+                </a:solidFill>
+                <a:latin typeface="Aptos" pitchFamily="34" charset="0"/>
+                <a:ea typeface="Aptos" pitchFamily="34" charset="-122"/>
+                <a:cs typeface="Aptos" pitchFamily="34" charset="-120"/>
                 <a:hlinkClick r:id="rId2" invalidUrl="" action="" tgtFrame="" tooltip="" history="1" highlightClick="0" endSnd="0">
                   <a:extLst>
                     <a:ext uri="{A12FA001-AC4F-418D-AE19-62706E023703}">
@@ -1541,25 +1704,25 @@
                   </a:extLst>
                 </a:hlinkClick>
               </a:rPr>
-              <a:t>10-challenge visual tour</a:t>
-            </a:r>
-            <a:endParaRPr lang="en-US" sz="950" dirty="0"/>
-          </a:p>
-          <a:p>
-            <a:pPr indent="0" marL="0">
-              <a:spcAft>
-                <a:spcPts val="400"/>
-              </a:spcAft>
-              <a:buNone/>
-            </a:pPr>
-            <a:r>
-              <a:rPr lang="en-US" sz="950" u="sng" dirty="0">
-                <a:solidFill>
-                  <a:srgbClr val="2E74B5"/>
-                </a:solidFill>
-                <a:latin typeface="Segoe UI" pitchFamily="34" charset="0"/>
-                <a:ea typeface="Segoe UI" pitchFamily="34" charset="-122"/>
-                <a:cs typeface="Segoe UI" pitchFamily="34" charset="-120"/>
+              <a:t>Live blueprint site</a:t>
+            </a:r>
+            <a:endParaRPr lang="en-US" sz="930" dirty="0"/>
+          </a:p>
+          <a:p>
+            <a:pPr indent="0" marL="0">
+              <a:spcAft>
+                <a:spcPts val="350"/>
+              </a:spcAft>
+              <a:buNone/>
+            </a:pPr>
+            <a:r>
+              <a:rPr lang="en-US" sz="930" u="sng" dirty="0">
+                <a:solidFill>
+                  <a:srgbClr val="1A77E3"/>
+                </a:solidFill>
+                <a:latin typeface="Aptos" pitchFamily="34" charset="0"/>
+                <a:ea typeface="Aptos" pitchFamily="34" charset="-122"/>
+                <a:cs typeface="Aptos" pitchFamily="34" charset="-120"/>
                 <a:hlinkClick r:id="rId3" invalidUrl="" action="" tgtFrame="" tooltip="" history="1" highlightClick="0" endSnd="0">
                   <a:extLst>
                     <a:ext uri="{A12FA001-AC4F-418D-AE19-62706E023703}">
@@ -1568,22 +1731,76 @@
                   </a:extLst>
                 </a:hlinkClick>
               </a:rPr>
-              <a:t>Facilitator delivery guide</a:t>
-            </a:r>
-            <a:endParaRPr lang="en-US" sz="950" dirty="0"/>
+              <a:t>Compose a delivery — Builder</a:t>
+            </a:r>
+            <a:endParaRPr lang="en-US" sz="930" dirty="0"/>
+          </a:p>
+          <a:p>
+            <a:pPr indent="0" marL="0">
+              <a:spcAft>
+                <a:spcPts val="350"/>
+              </a:spcAft>
+              <a:buNone/>
+            </a:pPr>
+            <a:r>
+              <a:rPr lang="en-US" sz="930" u="sng" dirty="0">
+                <a:solidFill>
+                  <a:srgbClr val="1A77E3"/>
+                </a:solidFill>
+                <a:latin typeface="Aptos" pitchFamily="34" charset="0"/>
+                <a:ea typeface="Aptos" pitchFamily="34" charset="-122"/>
+                <a:cs typeface="Aptos" pitchFamily="34" charset="-120"/>
+                <a:hlinkClick r:id="rId4" invalidUrl="" action="" tgtFrame="" tooltip="" history="1" highlightClick="0" endSnd="0">
+                  <a:extLst>
+                    <a:ext uri="{A12FA001-AC4F-418D-AE19-62706E023703}">
+                      <ahyp:hlinkClr xmlns:ahyp="http://schemas.microsoft.com/office/drawing/2018/hyperlinkcolor" val="tx"/>
+                    </a:ext>
+                  </a:extLst>
+                </a:hlinkClick>
+              </a:rPr>
+              <a:t>10-challenge visual tour</a:t>
+            </a:r>
+            <a:endParaRPr lang="en-US" sz="930" dirty="0"/>
+          </a:p>
+          <a:p>
+            <a:pPr indent="0" marL="0">
+              <a:spcAft>
+                <a:spcPts val="350"/>
+              </a:spcAft>
+              <a:buNone/>
+            </a:pPr>
+            <a:r>
+              <a:rPr lang="en-US" sz="930" u="sng" dirty="0">
+                <a:solidFill>
+                  <a:srgbClr val="1A77E3"/>
+                </a:solidFill>
+                <a:latin typeface="Aptos" pitchFamily="34" charset="0"/>
+                <a:ea typeface="Aptos" pitchFamily="34" charset="-122"/>
+                <a:cs typeface="Aptos" pitchFamily="34" charset="-120"/>
+                <a:hlinkClick r:id="rId5" invalidUrl="" action="" tgtFrame="" tooltip="" history="1" highlightClick="0" endSnd="0">
+                  <a:extLst>
+                    <a:ext uri="{A12FA001-AC4F-418D-AE19-62706E023703}">
+                      <ahyp:hlinkClr xmlns:ahyp="http://schemas.microsoft.com/office/drawing/2018/hyperlinkcolor" val="tx"/>
+                    </a:ext>
+                  </a:extLst>
+                </a:hlinkClick>
+              </a:rPr>
+              <a:t>GitHub repository</a:t>
+            </a:r>
+            <a:endParaRPr lang="en-US" sz="930" dirty="0"/>
           </a:p>
         </p:txBody>
       </p:sp>
       <p:sp>
         <p:nvSpPr>
-          <p:cNvPr id="17" name="Text 15"/>
-          <p:cNvSpPr/>
-          <p:nvPr/>
-        </p:nvSpPr>
-        <p:spPr>
-          <a:xfrm>
-            <a:off x="9217152" y="2148840"/>
-            <a:ext cx="2560320" cy="201168"/>
+          <p:cNvPr id="25" name="Text 22"/>
+          <p:cNvSpPr/>
+          <p:nvPr/>
+        </p:nvSpPr>
+        <p:spPr>
+          <a:xfrm>
+            <a:off x="9217152" y="2276856"/>
+            <a:ext cx="2651760" cy="201168"/>
           </a:xfrm>
           <a:prstGeom prst="rect">
             <a:avLst/>
@@ -1601,13 +1818,13 @@
             <a:r>
               <a:rPr lang="en-US" sz="1150" b="1" dirty="0">
                 <a:solidFill>
-                  <a:srgbClr val="1F4E79"/>
-                </a:solidFill>
-                <a:latin typeface="Segoe UI" pitchFamily="34" charset="0"/>
-                <a:ea typeface="Segoe UI" pitchFamily="34" charset="-122"/>
-                <a:cs typeface="Segoe UI" pitchFamily="34" charset="-120"/>
-              </a:rPr>
-              <a:t>Delivery:</a:t>
+                  <a:srgbClr val="032254"/>
+                </a:solidFill>
+                <a:latin typeface="Aptos Display" pitchFamily="34" charset="0"/>
+                <a:ea typeface="Aptos Display" pitchFamily="34" charset="-122"/>
+                <a:cs typeface="Aptos Display" pitchFamily="34" charset="-120"/>
+              </a:rPr>
+              <a:t>Delivery formats</a:t>
             </a:r>
             <a:endParaRPr lang="en-US" sz="1150" dirty="0"/>
           </a:p>
@@ -1615,14 +1832,14 @@
       </p:sp>
       <p:sp>
         <p:nvSpPr>
-          <p:cNvPr id="18" name="Text 16"/>
-          <p:cNvSpPr/>
-          <p:nvPr/>
-        </p:nvSpPr>
-        <p:spPr>
-          <a:xfrm>
-            <a:off x="9326880" y="2359152"/>
-            <a:ext cx="2487168" cy="749808"/>
+          <p:cNvPr id="26" name="Text 23"/>
+          <p:cNvSpPr/>
+          <p:nvPr/>
+        </p:nvSpPr>
+        <p:spPr>
+          <a:xfrm>
+            <a:off x="9326880" y="2487168"/>
+            <a:ext cx="2505456" cy="694944"/>
           </a:xfrm>
           <a:prstGeom prst="rect">
             <a:avLst/>
@@ -1636,120 +1853,120 @@
           <a:p>
             <a:pPr marL="342900" indent="-342900">
               <a:spcAft>
-                <a:spcPts val="150"/>
+                <a:spcPts val="180"/>
               </a:spcAft>
               <a:buSzPct val="100000"/>
               <a:buChar char="•"/>
             </a:pPr>
             <a:r>
-              <a:rPr lang="en-US" sz="830" dirty="0">
-                <a:solidFill>
-                  <a:srgbClr val="404040"/>
-                </a:solidFill>
-                <a:latin typeface="Segoe UI" pitchFamily="34" charset="0"/>
-                <a:ea typeface="Segoe UI" pitchFamily="34" charset="-122"/>
-                <a:cs typeface="Segoe UI" pitchFamily="34" charset="-120"/>
+              <a:rPr lang="en-US" sz="840" dirty="0">
+                <a:solidFill>
+                  <a:srgbClr val="47494E"/>
+                </a:solidFill>
+                <a:latin typeface="Aptos" pitchFamily="34" charset="0"/>
+                <a:ea typeface="Aptos" pitchFamily="34" charset="-122"/>
+                <a:cs typeface="Aptos" pitchFamily="34" charset="-120"/>
               </a:rPr>
               <a:t>Express demo — 90 min</a:t>
             </a:r>
-            <a:endParaRPr lang="en-US" sz="830" dirty="0"/>
+            <a:endParaRPr lang="en-US" sz="840" dirty="0"/>
           </a:p>
           <a:p>
             <a:pPr marL="342900" indent="-342900">
               <a:spcAft>
-                <a:spcPts val="150"/>
+                <a:spcPts val="180"/>
               </a:spcAft>
               <a:buSzPct val="100000"/>
               <a:buChar char="•"/>
             </a:pPr>
             <a:r>
-              <a:rPr lang="en-US" sz="830" dirty="0">
-                <a:solidFill>
-                  <a:srgbClr val="404040"/>
-                </a:solidFill>
-                <a:latin typeface="Segoe UI" pitchFamily="34" charset="0"/>
-                <a:ea typeface="Segoe UI" pitchFamily="34" charset="-122"/>
-                <a:cs typeface="Segoe UI" pitchFamily="34" charset="-120"/>
+              <a:rPr lang="en-US" sz="840" dirty="0">
+                <a:solidFill>
+                  <a:srgbClr val="47494E"/>
+                </a:solidFill>
+                <a:latin typeface="Aptos" pitchFamily="34" charset="0"/>
+                <a:ea typeface="Aptos" pitchFamily="34" charset="-122"/>
+                <a:cs typeface="Aptos" pitchFamily="34" charset="-120"/>
               </a:rPr>
               <a:t>1-day immersion</a:t>
             </a:r>
-            <a:endParaRPr lang="en-US" sz="830" dirty="0"/>
+            <a:endParaRPr lang="en-US" sz="840" dirty="0"/>
           </a:p>
           <a:p>
             <a:pPr marL="342900" indent="-342900">
               <a:spcAft>
-                <a:spcPts val="150"/>
+                <a:spcPts val="180"/>
               </a:spcAft>
               <a:buSzPct val="100000"/>
               <a:buChar char="•"/>
             </a:pPr>
             <a:r>
-              <a:rPr lang="en-US" sz="830" b="1" dirty="0">
-                <a:solidFill>
-                  <a:srgbClr val="404040"/>
-                </a:solidFill>
-                <a:latin typeface="Segoe UI" pitchFamily="34" charset="0"/>
-                <a:ea typeface="Segoe UI" pitchFamily="34" charset="-122"/>
-                <a:cs typeface="Segoe UI" pitchFamily="34" charset="-120"/>
-              </a:rPr>
-              <a:t>2-day hackathon (default)</a:t>
-            </a:r>
-            <a:endParaRPr lang="en-US" sz="830" dirty="0"/>
+              <a:rPr lang="en-US" sz="840" b="1" dirty="0">
+                <a:solidFill>
+                  <a:srgbClr val="032254"/>
+                </a:solidFill>
+                <a:latin typeface="Aptos" pitchFamily="34" charset="0"/>
+                <a:ea typeface="Aptos" pitchFamily="34" charset="-122"/>
+                <a:cs typeface="Aptos" pitchFamily="34" charset="-120"/>
+              </a:rPr>
+              <a:t>2-day RVAS (default)</a:t>
+            </a:r>
+            <a:endParaRPr lang="en-US" sz="840" dirty="0"/>
           </a:p>
           <a:p>
             <a:pPr marL="342900" indent="-342900">
               <a:spcAft>
-                <a:spcPts val="150"/>
+                <a:spcPts val="180"/>
               </a:spcAft>
               <a:buSzPct val="100000"/>
               <a:buChar char="•"/>
             </a:pPr>
             <a:r>
-              <a:rPr lang="en-US" sz="830" dirty="0">
-                <a:solidFill>
-                  <a:srgbClr val="404040"/>
-                </a:solidFill>
-                <a:latin typeface="Segoe UI" pitchFamily="34" charset="0"/>
-                <a:ea typeface="Segoe UI" pitchFamily="34" charset="-122"/>
-                <a:cs typeface="Segoe UI" pitchFamily="34" charset="-120"/>
+              <a:rPr lang="en-US" sz="840" dirty="0">
+                <a:solidFill>
+                  <a:srgbClr val="47494E"/>
+                </a:solidFill>
+                <a:latin typeface="Aptos" pitchFamily="34" charset="0"/>
+                <a:ea typeface="Aptos" pitchFamily="34" charset="-122"/>
+                <a:cs typeface="Aptos" pitchFamily="34" charset="-120"/>
               </a:rPr>
               <a:t>Multi-week engagement</a:t>
             </a:r>
-            <a:endParaRPr lang="en-US" sz="830" dirty="0"/>
+            <a:endParaRPr lang="en-US" sz="840" dirty="0"/>
           </a:p>
           <a:p>
             <a:pPr marL="342900" indent="-342900">
               <a:spcAft>
-                <a:spcPts val="150"/>
+                <a:spcPts val="180"/>
               </a:spcAft>
               <a:buSzPct val="100000"/>
               <a:buChar char="•"/>
             </a:pPr>
             <a:r>
-              <a:rPr lang="en-US" sz="830" dirty="0">
-                <a:solidFill>
-                  <a:srgbClr val="404040"/>
-                </a:solidFill>
-                <a:latin typeface="Segoe UI" pitchFamily="34" charset="0"/>
-                <a:ea typeface="Segoe UI" pitchFamily="34" charset="-122"/>
-                <a:cs typeface="Segoe UI" pitchFamily="34" charset="-120"/>
+              <a:rPr lang="en-US" sz="840" dirty="0">
+                <a:solidFill>
+                  <a:srgbClr val="47494E"/>
+                </a:solidFill>
+                <a:latin typeface="Aptos" pitchFamily="34" charset="0"/>
+                <a:ea typeface="Aptos" pitchFamily="34" charset="-122"/>
+                <a:cs typeface="Aptos" pitchFamily="34" charset="-120"/>
               </a:rPr>
               <a:t>Self-paced enablement</a:t>
             </a:r>
-            <a:endParaRPr lang="en-US" sz="830" dirty="0"/>
+            <a:endParaRPr lang="en-US" sz="840" dirty="0"/>
           </a:p>
         </p:txBody>
       </p:sp>
       <p:sp>
         <p:nvSpPr>
-          <p:cNvPr id="19" name="Shape 17"/>
-          <p:cNvSpPr/>
-          <p:nvPr/>
-        </p:nvSpPr>
-        <p:spPr>
-          <a:xfrm>
-            <a:off x="256032" y="3236976"/>
-            <a:ext cx="11676888" cy="3108960"/>
+          <p:cNvPr id="27" name="Shape 24"/>
+          <p:cNvSpPr/>
+          <p:nvPr/>
+        </p:nvSpPr>
+        <p:spPr>
+          <a:xfrm>
+            <a:off x="256032" y="3291840"/>
+            <a:ext cx="11676888" cy="2926080"/>
           </a:xfrm>
           <a:prstGeom prst="rect">
             <a:avLst/>
@@ -1759,7 +1976,7 @@
           </a:solidFill>
           <a:ln w="12700">
             <a:solidFill>
-              <a:srgbClr val="BFBFBF"/>
+              <a:srgbClr val="E3E6ED"/>
             </a:solidFill>
             <a:prstDash val="solid"/>
           </a:ln>
@@ -1767,13 +1984,33 @@
       </p:sp>
       <p:sp>
         <p:nvSpPr>
-          <p:cNvPr id="20" name="Text 18"/>
-          <p:cNvSpPr/>
-          <p:nvPr/>
-        </p:nvSpPr>
-        <p:spPr>
-          <a:xfrm>
-            <a:off x="402336" y="3273552"/>
+          <p:cNvPr id="28" name="Shape 25"/>
+          <p:cNvSpPr/>
+          <p:nvPr/>
+        </p:nvSpPr>
+        <p:spPr>
+          <a:xfrm>
+            <a:off x="256032" y="3291840"/>
+            <a:ext cx="11676888" cy="54864"/>
+          </a:xfrm>
+          <a:prstGeom prst="rect">
+            <a:avLst/>
+          </a:prstGeom>
+          <a:solidFill>
+            <a:srgbClr val="032254"/>
+          </a:solidFill>
+          <a:ln/>
+        </p:spPr>
+      </p:sp>
+      <p:sp>
+        <p:nvSpPr>
+          <p:cNvPr id="29" name="Text 26"/>
+          <p:cNvSpPr/>
+          <p:nvPr/>
+        </p:nvSpPr>
+        <p:spPr>
+          <a:xfrm>
+            <a:off x="402336" y="3364992"/>
             <a:ext cx="5486400" cy="310896"/>
           </a:xfrm>
           <a:prstGeom prst="rect">
@@ -1792,13 +2029,13 @@
             <a:r>
               <a:rPr lang="en-US" sz="1650" b="1" dirty="0">
                 <a:solidFill>
-                  <a:srgbClr val="1F3864"/>
-                </a:solidFill>
-                <a:latin typeface="Segoe UI" pitchFamily="34" charset="0"/>
-                <a:ea typeface="Segoe UI" pitchFamily="34" charset="-122"/>
-                <a:cs typeface="Segoe UI" pitchFamily="34" charset="-120"/>
-              </a:rPr>
-              <a:t>Hackathon Journey.</a:t>
+                  <a:srgbClr val="032254"/>
+                </a:solidFill>
+                <a:latin typeface="Aptos Display" pitchFamily="34" charset="0"/>
+                <a:ea typeface="Aptos Display" pitchFamily="34" charset="-122"/>
+                <a:cs typeface="Aptos Display" pitchFamily="34" charset="-120"/>
+              </a:rPr>
+              <a:t>The RVAS journey</a:t>
             </a:r>
             <a:endParaRPr lang="en-US" sz="1650" dirty="0"/>
           </a:p>
@@ -1806,20 +2043,203 @@
       </p:sp>
       <p:sp>
         <p:nvSpPr>
-          <p:cNvPr id="21" name="Shape 19"/>
-          <p:cNvSpPr/>
-          <p:nvPr/>
-        </p:nvSpPr>
-        <p:spPr>
-          <a:xfrm>
-            <a:off x="365760" y="3639312"/>
-            <a:ext cx="2291486" cy="603504"/>
-          </a:xfrm>
-          <a:prstGeom prst="rect">
-            <a:avLst/>
+          <p:cNvPr id="30" name="Shape 27"/>
+          <p:cNvSpPr/>
+          <p:nvPr/>
+        </p:nvSpPr>
+        <p:spPr>
+          <a:xfrm>
+            <a:off x="8238744" y="3383280"/>
+            <a:ext cx="1133856" cy="274320"/>
+          </a:xfrm>
+          <a:prstGeom prst="roundRect">
+            <a:avLst>
+              <a:gd name="adj" fmla="val 20000"/>
+            </a:avLst>
           </a:prstGeom>
           <a:solidFill>
-            <a:srgbClr val="0B5394"/>
+            <a:srgbClr val="DDE6F7"/>
+          </a:solidFill>
+          <a:ln/>
+        </p:spPr>
+      </p:sp>
+      <p:sp>
+        <p:nvSpPr>
+          <p:cNvPr id="31" name="Text 28"/>
+          <p:cNvSpPr/>
+          <p:nvPr/>
+        </p:nvSpPr>
+        <p:spPr>
+          <a:xfrm>
+            <a:off x="8238744" y="3383280"/>
+            <a:ext cx="1133856" cy="274320"/>
+          </a:xfrm>
+          <a:prstGeom prst="rect">
+            <a:avLst/>
+          </a:prstGeom>
+          <a:noFill/>
+          <a:ln/>
+        </p:spPr>
+        <p:txBody>
+          <a:bodyPr wrap="square" lIns="0" tIns="0" rIns="0" bIns="0" rtlCol="0" anchor="ctr"/>
+          <a:lstStyle/>
+          <a:p>
+            <a:pPr algn="ctr" indent="0" marL="0">
+              <a:buNone/>
+            </a:pPr>
+            <a:r>
+              <a:rPr lang="en-US" sz="900" b="1" spc="100" kern="0" dirty="0">
+                <a:solidFill>
+                  <a:srgbClr val="0078D4"/>
+                </a:solidFill>
+                <a:latin typeface="Aptos Display" pitchFamily="34" charset="0"/>
+                <a:ea typeface="Aptos Display" pitchFamily="34" charset="-122"/>
+                <a:cs typeface="Aptos Display" pitchFamily="34" charset="-120"/>
+              </a:rPr>
+              <a:t>BUILD</a:t>
+            </a:r>
+            <a:endParaRPr lang="en-US" sz="900" dirty="0"/>
+          </a:p>
+        </p:txBody>
+      </p:sp>
+      <p:sp>
+        <p:nvSpPr>
+          <p:cNvPr id="32" name="Shape 29"/>
+          <p:cNvSpPr/>
+          <p:nvPr/>
+        </p:nvSpPr>
+        <p:spPr>
+          <a:xfrm>
+            <a:off x="9464040" y="3383280"/>
+            <a:ext cx="1133856" cy="274320"/>
+          </a:xfrm>
+          <a:prstGeom prst="roundRect">
+            <a:avLst>
+              <a:gd name="adj" fmla="val 20000"/>
+            </a:avLst>
+          </a:prstGeom>
+          <a:solidFill>
+            <a:srgbClr val="EDE9F7"/>
+          </a:solidFill>
+          <a:ln/>
+        </p:spPr>
+      </p:sp>
+      <p:sp>
+        <p:nvSpPr>
+          <p:cNvPr id="33" name="Text 30"/>
+          <p:cNvSpPr/>
+          <p:nvPr/>
+        </p:nvSpPr>
+        <p:spPr>
+          <a:xfrm>
+            <a:off x="9464040" y="3383280"/>
+            <a:ext cx="1133856" cy="274320"/>
+          </a:xfrm>
+          <a:prstGeom prst="rect">
+            <a:avLst/>
+          </a:prstGeom>
+          <a:noFill/>
+          <a:ln/>
+        </p:spPr>
+        <p:txBody>
+          <a:bodyPr wrap="square" lIns="0" tIns="0" rIns="0" bIns="0" rtlCol="0" anchor="ctr"/>
+          <a:lstStyle/>
+          <a:p>
+            <a:pPr algn="ctr" indent="0" marL="0">
+              <a:buNone/>
+            </a:pPr>
+            <a:r>
+              <a:rPr lang="en-US" sz="900" b="1" spc="100" kern="0" dirty="0">
+                <a:solidFill>
+                  <a:srgbClr val="504092"/>
+                </a:solidFill>
+                <a:latin typeface="Aptos Display" pitchFamily="34" charset="0"/>
+                <a:ea typeface="Aptos Display" pitchFamily="34" charset="-122"/>
+                <a:cs typeface="Aptos Display" pitchFamily="34" charset="-120"/>
+              </a:rPr>
+              <a:t>INNOVATE</a:t>
+            </a:r>
+            <a:endParaRPr lang="en-US" sz="900" dirty="0"/>
+          </a:p>
+        </p:txBody>
+      </p:sp>
+      <p:sp>
+        <p:nvSpPr>
+          <p:cNvPr id="34" name="Shape 31"/>
+          <p:cNvSpPr/>
+          <p:nvPr/>
+        </p:nvSpPr>
+        <p:spPr>
+          <a:xfrm>
+            <a:off x="10689336" y="3383280"/>
+            <a:ext cx="1133856" cy="274320"/>
+          </a:xfrm>
+          <a:prstGeom prst="roundRect">
+            <a:avLst>
+              <a:gd name="adj" fmla="val 20000"/>
+            </a:avLst>
+          </a:prstGeom>
+          <a:solidFill>
+            <a:srgbClr val="D6EBEB"/>
+          </a:solidFill>
+          <a:ln/>
+        </p:spPr>
+      </p:sp>
+      <p:sp>
+        <p:nvSpPr>
+          <p:cNvPr id="35" name="Text 32"/>
+          <p:cNvSpPr/>
+          <p:nvPr/>
+        </p:nvSpPr>
+        <p:spPr>
+          <a:xfrm>
+            <a:off x="10689336" y="3383280"/>
+            <a:ext cx="1133856" cy="274320"/>
+          </a:xfrm>
+          <a:prstGeom prst="rect">
+            <a:avLst/>
+          </a:prstGeom>
+          <a:noFill/>
+          <a:ln/>
+        </p:spPr>
+        <p:txBody>
+          <a:bodyPr wrap="square" lIns="0" tIns="0" rIns="0" bIns="0" rtlCol="0" anchor="ctr"/>
+          <a:lstStyle/>
+          <a:p>
+            <a:pPr algn="ctr" indent="0" marL="0">
+              <a:buNone/>
+            </a:pPr>
+            <a:r>
+              <a:rPr lang="en-US" sz="900" b="1" spc="100" kern="0" dirty="0">
+                <a:solidFill>
+                  <a:srgbClr val="14868A"/>
+                </a:solidFill>
+                <a:latin typeface="Aptos Display" pitchFamily="34" charset="0"/>
+                <a:ea typeface="Aptos Display" pitchFamily="34" charset="-122"/>
+                <a:cs typeface="Aptos Display" pitchFamily="34" charset="-120"/>
+              </a:rPr>
+              <a:t>SCALE</a:t>
+            </a:r>
+            <a:endParaRPr lang="en-US" sz="900" dirty="0"/>
+          </a:p>
+        </p:txBody>
+      </p:sp>
+      <p:sp>
+        <p:nvSpPr>
+          <p:cNvPr id="36" name="Shape 33"/>
+          <p:cNvSpPr/>
+          <p:nvPr/>
+        </p:nvSpPr>
+        <p:spPr>
+          <a:xfrm>
+            <a:off x="365760" y="3749040"/>
+            <a:ext cx="2291486" cy="548640"/>
+          </a:xfrm>
+          <a:prstGeom prst="rect">
+            <a:avLst/>
+          </a:prstGeom>
+          <a:solidFill>
+            <a:srgbClr val="032254"/>
           </a:solidFill>
           <a:ln w="12700">
             <a:solidFill>
@@ -1831,14 +2251,14 @@
       </p:sp>
       <p:sp>
         <p:nvSpPr>
-          <p:cNvPr id="22" name="Text 20"/>
-          <p:cNvSpPr/>
-          <p:nvPr/>
-        </p:nvSpPr>
-        <p:spPr>
-          <a:xfrm>
-            <a:off x="411480" y="3639312"/>
-            <a:ext cx="2200046" cy="603504"/>
+          <p:cNvPr id="37" name="Text 34"/>
+          <p:cNvSpPr/>
+          <p:nvPr/>
+        </p:nvSpPr>
+        <p:spPr>
+          <a:xfrm>
+            <a:off x="411480" y="3749040"/>
+            <a:ext cx="2200046" cy="548640"/>
           </a:xfrm>
           <a:prstGeom prst="rect">
             <a:avLst/>
@@ -1861,9 +2281,9 @@
                 <a:solidFill>
                   <a:srgbClr val="FFFFFF"/>
                 </a:solidFill>
-                <a:latin typeface="Segoe UI" pitchFamily="34" charset="0"/>
-                <a:ea typeface="Segoe UI" pitchFamily="34" charset="-122"/>
-                <a:cs typeface="Segoe UI" pitchFamily="34" charset="-120"/>
+                <a:latin typeface="Aptos" pitchFamily="34" charset="0"/>
+                <a:ea typeface="Aptos" pitchFamily="34" charset="-122"/>
+                <a:cs typeface="Aptos" pitchFamily="34" charset="-120"/>
               </a:rPr>
               <a:t>STEP 1</a:t>
             </a:r>
@@ -1881,9 +2301,9 @@
                 <a:solidFill>
                   <a:srgbClr val="FFFFFF"/>
                 </a:solidFill>
-                <a:latin typeface="Segoe UI" pitchFamily="34" charset="0"/>
-                <a:ea typeface="Segoe UI" pitchFamily="34" charset="-122"/>
-                <a:cs typeface="Segoe UI" pitchFamily="34" charset="-120"/>
+                <a:latin typeface="Aptos Display" pitchFamily="34" charset="0"/>
+                <a:ea typeface="Aptos Display" pitchFamily="34" charset="-122"/>
+                <a:cs typeface="Aptos Display" pitchFamily="34" charset="-120"/>
               </a:rPr>
               <a:t>FOUNDATION</a:t>
             </a:r>
@@ -1901,9 +2321,9 @@
                 <a:solidFill>
                   <a:srgbClr val="EAF0F9"/>
                 </a:solidFill>
-                <a:latin typeface="Segoe UI" pitchFamily="34" charset="0"/>
-                <a:ea typeface="Segoe UI" pitchFamily="34" charset="-122"/>
-                <a:cs typeface="Segoe UI" pitchFamily="34" charset="-120"/>
+                <a:latin typeface="Aptos" pitchFamily="34" charset="0"/>
+                <a:ea typeface="Aptos" pitchFamily="34" charset="-122"/>
+                <a:cs typeface="Aptos" pitchFamily="34" charset="-120"/>
               </a:rPr>
               <a:t>Make the tenant agent-ready</a:t>
             </a:r>
@@ -1913,20 +2333,20 @@
       </p:sp>
       <p:sp>
         <p:nvSpPr>
-          <p:cNvPr id="23" name="Shape 21"/>
-          <p:cNvSpPr/>
-          <p:nvPr/>
-        </p:nvSpPr>
-        <p:spPr>
-          <a:xfrm>
-            <a:off x="2657246" y="3639312"/>
-            <a:ext cx="2291486" cy="603504"/>
+          <p:cNvPr id="38" name="Shape 35"/>
+          <p:cNvSpPr/>
+          <p:nvPr/>
+        </p:nvSpPr>
+        <p:spPr>
+          <a:xfrm>
+            <a:off x="2657246" y="3749040"/>
+            <a:ext cx="2291486" cy="548640"/>
           </a:xfrm>
           <a:prstGeom prst="rect">
             <a:avLst/>
           </a:prstGeom>
           <a:solidFill>
-            <a:srgbClr val="1155CC"/>
+            <a:srgbClr val="1A77E3"/>
           </a:solidFill>
           <a:ln w="12700">
             <a:solidFill>
@@ -1938,14 +2358,14 @@
       </p:sp>
       <p:sp>
         <p:nvSpPr>
-          <p:cNvPr id="24" name="Text 22"/>
-          <p:cNvSpPr/>
-          <p:nvPr/>
-        </p:nvSpPr>
-        <p:spPr>
-          <a:xfrm>
-            <a:off x="2702966" y="3639312"/>
-            <a:ext cx="2200046" cy="603504"/>
+          <p:cNvPr id="39" name="Text 36"/>
+          <p:cNvSpPr/>
+          <p:nvPr/>
+        </p:nvSpPr>
+        <p:spPr>
+          <a:xfrm>
+            <a:off x="2702966" y="3749040"/>
+            <a:ext cx="2200046" cy="548640"/>
           </a:xfrm>
           <a:prstGeom prst="rect">
             <a:avLst/>
@@ -1968,9 +2388,9 @@
                 <a:solidFill>
                   <a:srgbClr val="FFFFFF"/>
                 </a:solidFill>
-                <a:latin typeface="Segoe UI" pitchFamily="34" charset="0"/>
-                <a:ea typeface="Segoe UI" pitchFamily="34" charset="-122"/>
-                <a:cs typeface="Segoe UI" pitchFamily="34" charset="-120"/>
+                <a:latin typeface="Aptos" pitchFamily="34" charset="0"/>
+                <a:ea typeface="Aptos" pitchFamily="34" charset="-122"/>
+                <a:cs typeface="Aptos" pitchFamily="34" charset="-120"/>
               </a:rPr>
               <a:t>STEP 2</a:t>
             </a:r>
@@ -1988,9 +2408,9 @@
                 <a:solidFill>
                   <a:srgbClr val="FFFFFF"/>
                 </a:solidFill>
-                <a:latin typeface="Segoe UI" pitchFamily="34" charset="0"/>
-                <a:ea typeface="Segoe UI" pitchFamily="34" charset="-122"/>
-                <a:cs typeface="Segoe UI" pitchFamily="34" charset="-120"/>
+                <a:latin typeface="Aptos Display" pitchFamily="34" charset="0"/>
+                <a:ea typeface="Aptos Display" pitchFamily="34" charset="-122"/>
+                <a:cs typeface="Aptos Display" pitchFamily="34" charset="-120"/>
               </a:rPr>
               <a:t>CORE LOOP</a:t>
             </a:r>
@@ -2008,9 +2428,9 @@
                 <a:solidFill>
                   <a:srgbClr val="EAF0F9"/>
                 </a:solidFill>
-                <a:latin typeface="Segoe UI" pitchFamily="34" charset="0"/>
-                <a:ea typeface="Segoe UI" pitchFamily="34" charset="-122"/>
-                <a:cs typeface="Segoe UI" pitchFamily="34" charset="-120"/>
+                <a:latin typeface="Aptos" pitchFamily="34" charset="0"/>
+                <a:ea typeface="Aptos" pitchFamily="34" charset="-122"/>
+                <a:cs typeface="Aptos" pitchFamily="34" charset="-120"/>
               </a:rPr>
               <a:t>Nothing exists without a PR</a:t>
             </a:r>
@@ -2020,20 +2440,20 @@
       </p:sp>
       <p:sp>
         <p:nvSpPr>
-          <p:cNvPr id="25" name="Shape 23"/>
-          <p:cNvSpPr/>
-          <p:nvPr/>
-        </p:nvSpPr>
-        <p:spPr>
-          <a:xfrm>
-            <a:off x="4948733" y="3639312"/>
-            <a:ext cx="2291486" cy="603504"/>
+          <p:cNvPr id="40" name="Shape 37"/>
+          <p:cNvSpPr/>
+          <p:nvPr/>
+        </p:nvSpPr>
+        <p:spPr>
+          <a:xfrm>
+            <a:off x="4948733" y="3749040"/>
+            <a:ext cx="2291486" cy="548640"/>
           </a:xfrm>
           <a:prstGeom prst="rect">
             <a:avLst/>
           </a:prstGeom>
           <a:solidFill>
-            <a:srgbClr val="0F9D58"/>
+            <a:srgbClr val="0078D4"/>
           </a:solidFill>
           <a:ln w="12700">
             <a:solidFill>
@@ -2045,14 +2465,14 @@
       </p:sp>
       <p:sp>
         <p:nvSpPr>
-          <p:cNvPr id="26" name="Text 24"/>
-          <p:cNvSpPr/>
-          <p:nvPr/>
-        </p:nvSpPr>
-        <p:spPr>
-          <a:xfrm>
-            <a:off x="4994453" y="3639312"/>
-            <a:ext cx="2200046" cy="603504"/>
+          <p:cNvPr id="41" name="Text 38"/>
+          <p:cNvSpPr/>
+          <p:nvPr/>
+        </p:nvSpPr>
+        <p:spPr>
+          <a:xfrm>
+            <a:off x="4994453" y="3749040"/>
+            <a:ext cx="2200046" cy="548640"/>
           </a:xfrm>
           <a:prstGeom prst="rect">
             <a:avLst/>
@@ -2075,9 +2495,9 @@
                 <a:solidFill>
                   <a:srgbClr val="FFFFFF"/>
                 </a:solidFill>
-                <a:latin typeface="Segoe UI" pitchFamily="34" charset="0"/>
-                <a:ea typeface="Segoe UI" pitchFamily="34" charset="-122"/>
-                <a:cs typeface="Segoe UI" pitchFamily="34" charset="-120"/>
+                <a:latin typeface="Aptos" pitchFamily="34" charset="0"/>
+                <a:ea typeface="Aptos" pitchFamily="34" charset="-122"/>
+                <a:cs typeface="Aptos" pitchFamily="34" charset="-120"/>
               </a:rPr>
               <a:t>STEP 3</a:t>
             </a:r>
@@ -2095,9 +2515,9 @@
                 <a:solidFill>
                   <a:srgbClr val="FFFFFF"/>
                 </a:solidFill>
-                <a:latin typeface="Segoe UI" pitchFamily="34" charset="0"/>
-                <a:ea typeface="Segoe UI" pitchFamily="34" charset="-122"/>
-                <a:cs typeface="Segoe UI" pitchFamily="34" charset="-120"/>
+                <a:latin typeface="Aptos Display" pitchFamily="34" charset="0"/>
+                <a:ea typeface="Aptos Display" pitchFamily="34" charset="-122"/>
+                <a:cs typeface="Aptos Display" pitchFamily="34" charset="-120"/>
               </a:rPr>
               <a:t>GOVERNED CONTROL PLANE</a:t>
             </a:r>
@@ -2115,9 +2535,9 @@
                 <a:solidFill>
                   <a:srgbClr val="EAF0F9"/>
                 </a:solidFill>
-                <a:latin typeface="Segoe UI" pitchFamily="34" charset="0"/>
-                <a:ea typeface="Segoe UI" pitchFamily="34" charset="-122"/>
-                <a:cs typeface="Segoe UI" pitchFamily="34" charset="-120"/>
+                <a:latin typeface="Aptos" pitchFamily="34" charset="0"/>
+                <a:ea typeface="Aptos" pitchFamily="34" charset="-122"/>
+                <a:cs typeface="Aptos" pitchFamily="34" charset="-120"/>
               </a:rPr>
               <a:t>Front-door governance</a:t>
             </a:r>
@@ -2127,20 +2547,20 @@
       </p:sp>
       <p:sp>
         <p:nvSpPr>
-          <p:cNvPr id="27" name="Shape 25"/>
-          <p:cNvSpPr/>
-          <p:nvPr/>
-        </p:nvSpPr>
-        <p:spPr>
-          <a:xfrm>
-            <a:off x="7240219" y="3639312"/>
-            <a:ext cx="2291486" cy="603504"/>
+          <p:cNvPr id="42" name="Shape 39"/>
+          <p:cNvSpPr/>
+          <p:nvPr/>
+        </p:nvSpPr>
+        <p:spPr>
+          <a:xfrm>
+            <a:off x="7240219" y="3749040"/>
+            <a:ext cx="2291486" cy="548640"/>
           </a:xfrm>
           <a:prstGeom prst="rect">
             <a:avLst/>
           </a:prstGeom>
           <a:solidFill>
-            <a:srgbClr val="E0730C"/>
+            <a:srgbClr val="504092"/>
           </a:solidFill>
           <a:ln w="12700">
             <a:solidFill>
@@ -2152,14 +2572,14 @@
       </p:sp>
       <p:sp>
         <p:nvSpPr>
-          <p:cNvPr id="28" name="Text 26"/>
-          <p:cNvSpPr/>
-          <p:nvPr/>
-        </p:nvSpPr>
-        <p:spPr>
-          <a:xfrm>
-            <a:off x="7285939" y="3639312"/>
-            <a:ext cx="2200046" cy="603504"/>
+          <p:cNvPr id="43" name="Text 40"/>
+          <p:cNvSpPr/>
+          <p:nvPr/>
+        </p:nvSpPr>
+        <p:spPr>
+          <a:xfrm>
+            <a:off x="7285939" y="3749040"/>
+            <a:ext cx="2200046" cy="548640"/>
           </a:xfrm>
           <a:prstGeom prst="rect">
             <a:avLst/>
@@ -2182,9 +2602,9 @@
                 <a:solidFill>
                   <a:srgbClr val="FFFFFF"/>
                 </a:solidFill>
-                <a:latin typeface="Segoe UI" pitchFamily="34" charset="0"/>
-                <a:ea typeface="Segoe UI" pitchFamily="34" charset="-122"/>
-                <a:cs typeface="Segoe UI" pitchFamily="34" charset="-120"/>
+                <a:latin typeface="Aptos" pitchFamily="34" charset="0"/>
+                <a:ea typeface="Aptos" pitchFamily="34" charset="-122"/>
+                <a:cs typeface="Aptos" pitchFamily="34" charset="-120"/>
               </a:rPr>
               <a:t>STEP 4</a:t>
             </a:r>
@@ -2202,9 +2622,9 @@
                 <a:solidFill>
                   <a:srgbClr val="FFFFFF"/>
                 </a:solidFill>
-                <a:latin typeface="Segoe UI" pitchFamily="34" charset="0"/>
-                <a:ea typeface="Segoe UI" pitchFamily="34" charset="-122"/>
-                <a:cs typeface="Segoe UI" pitchFamily="34" charset="-120"/>
+                <a:latin typeface="Aptos Display" pitchFamily="34" charset="0"/>
+                <a:ea typeface="Aptos Display" pitchFamily="34" charset="-122"/>
+                <a:cs typeface="Aptos Display" pitchFamily="34" charset="-120"/>
               </a:rPr>
               <a:t>INTELLIGENT GOVERNANCE</a:t>
             </a:r>
@@ -2222,9 +2642,9 @@
                 <a:solidFill>
                   <a:srgbClr val="EAF0F9"/>
                 </a:solidFill>
-                <a:latin typeface="Segoe UI" pitchFamily="34" charset="0"/>
-                <a:ea typeface="Segoe UI" pitchFamily="34" charset="-122"/>
-                <a:cs typeface="Segoe UI" pitchFamily="34" charset="-120"/>
+                <a:latin typeface="Aptos" pitchFamily="34" charset="0"/>
+                <a:ea typeface="Aptos" pitchFamily="34" charset="-122"/>
+                <a:cs typeface="Aptos" pitchFamily="34" charset="-120"/>
               </a:rPr>
               <a:t>Scale with guardrails</a:t>
             </a:r>
@@ -2234,20 +2654,20 @@
       </p:sp>
       <p:sp>
         <p:nvSpPr>
-          <p:cNvPr id="29" name="Shape 27"/>
-          <p:cNvSpPr/>
-          <p:nvPr/>
-        </p:nvSpPr>
-        <p:spPr>
-          <a:xfrm>
-            <a:off x="9531706" y="3639312"/>
-            <a:ext cx="2291486" cy="603504"/>
+          <p:cNvPr id="44" name="Shape 41"/>
+          <p:cNvSpPr/>
+          <p:nvPr/>
+        </p:nvSpPr>
+        <p:spPr>
+          <a:xfrm>
+            <a:off x="9531706" y="3749040"/>
+            <a:ext cx="2291486" cy="548640"/>
           </a:xfrm>
           <a:prstGeom prst="rect">
             <a:avLst/>
           </a:prstGeom>
           <a:solidFill>
-            <a:srgbClr val="6A329F"/>
+            <a:srgbClr val="14868A"/>
           </a:solidFill>
           <a:ln w="12700">
             <a:solidFill>
@@ -2259,14 +2679,14 @@
       </p:sp>
       <p:sp>
         <p:nvSpPr>
-          <p:cNvPr id="30" name="Text 28"/>
-          <p:cNvSpPr/>
-          <p:nvPr/>
-        </p:nvSpPr>
-        <p:spPr>
-          <a:xfrm>
-            <a:off x="9577426" y="3639312"/>
-            <a:ext cx="2200046" cy="603504"/>
+          <p:cNvPr id="45" name="Text 42"/>
+          <p:cNvSpPr/>
+          <p:nvPr/>
+        </p:nvSpPr>
+        <p:spPr>
+          <a:xfrm>
+            <a:off x="9577426" y="3749040"/>
+            <a:ext cx="2200046" cy="548640"/>
           </a:xfrm>
           <a:prstGeom prst="rect">
             <a:avLst/>
@@ -2289,9 +2709,9 @@
                 <a:solidFill>
                   <a:srgbClr val="FFFFFF"/>
                 </a:solidFill>
-                <a:latin typeface="Segoe UI" pitchFamily="34" charset="0"/>
-                <a:ea typeface="Segoe UI" pitchFamily="34" charset="-122"/>
-                <a:cs typeface="Segoe UI" pitchFamily="34" charset="-120"/>
+                <a:latin typeface="Aptos" pitchFamily="34" charset="0"/>
+                <a:ea typeface="Aptos" pitchFamily="34" charset="-122"/>
+                <a:cs typeface="Aptos" pitchFamily="34" charset="-120"/>
               </a:rPr>
               <a:t>STEP 5</a:t>
             </a:r>
@@ -2309,9 +2729,9 @@
                 <a:solidFill>
                   <a:srgbClr val="FFFFFF"/>
                 </a:solidFill>
-                <a:latin typeface="Segoe UI" pitchFamily="34" charset="0"/>
-                <a:ea typeface="Segoe UI" pitchFamily="34" charset="-122"/>
-                <a:cs typeface="Segoe UI" pitchFamily="34" charset="-120"/>
+                <a:latin typeface="Aptos Display" pitchFamily="34" charset="0"/>
+                <a:ea typeface="Aptos Display" pitchFamily="34" charset="-122"/>
+                <a:cs typeface="Aptos Display" pitchFamily="34" charset="-120"/>
               </a:rPr>
               <a:t>CAPSTONE &amp; EVOLVE</a:t>
             </a:r>
@@ -2329,9 +2749,9 @@
                 <a:solidFill>
                   <a:srgbClr val="EAF0F9"/>
                 </a:solidFill>
-                <a:latin typeface="Segoe UI" pitchFamily="34" charset="0"/>
-                <a:ea typeface="Segoe UI" pitchFamily="34" charset="-122"/>
-                <a:cs typeface="Segoe UI" pitchFamily="34" charset="-120"/>
+                <a:latin typeface="Aptos" pitchFamily="34" charset="0"/>
+                <a:ea typeface="Aptos" pitchFamily="34" charset="-122"/>
+                <a:cs typeface="Aptos" pitchFamily="34" charset="-120"/>
               </a:rPr>
               <a:t>Prove it, then compound it</a:t>
             </a:r>
@@ -2341,14 +2761,14 @@
       </p:sp>
       <p:sp>
         <p:nvSpPr>
-          <p:cNvPr id="31" name="Shape 29"/>
-          <p:cNvSpPr/>
-          <p:nvPr/>
-        </p:nvSpPr>
-        <p:spPr>
-          <a:xfrm>
-            <a:off x="2657246" y="4297680"/>
-            <a:ext cx="0" cy="1956816"/>
+          <p:cNvPr id="46" name="Shape 43"/>
+          <p:cNvSpPr/>
+          <p:nvPr/>
+        </p:nvSpPr>
+        <p:spPr>
+          <a:xfrm>
+            <a:off x="2657246" y="4361688"/>
+            <a:ext cx="0" cy="1764792"/>
           </a:xfrm>
           <a:prstGeom prst="line">
             <a:avLst/>
@@ -2356,7 +2776,7 @@
           <a:noFill/>
           <a:ln w="9525">
             <a:solidFill>
-              <a:srgbClr val="D9D9D9"/>
+              <a:srgbClr val="E3E6ED"/>
             </a:solidFill>
             <a:prstDash val="solid"/>
           </a:ln>
@@ -2364,14 +2784,14 @@
       </p:sp>
       <p:sp>
         <p:nvSpPr>
-          <p:cNvPr id="32" name="Shape 30"/>
-          <p:cNvSpPr/>
-          <p:nvPr/>
-        </p:nvSpPr>
-        <p:spPr>
-          <a:xfrm>
-            <a:off x="4948733" y="4297680"/>
-            <a:ext cx="0" cy="1956816"/>
+          <p:cNvPr id="47" name="Shape 44"/>
+          <p:cNvSpPr/>
+          <p:nvPr/>
+        </p:nvSpPr>
+        <p:spPr>
+          <a:xfrm>
+            <a:off x="4948733" y="4361688"/>
+            <a:ext cx="0" cy="1764792"/>
           </a:xfrm>
           <a:prstGeom prst="line">
             <a:avLst/>
@@ -2379,7 +2799,7 @@
           <a:noFill/>
           <a:ln w="9525">
             <a:solidFill>
-              <a:srgbClr val="D9D9D9"/>
+              <a:srgbClr val="E3E6ED"/>
             </a:solidFill>
             <a:prstDash val="solid"/>
           </a:ln>
@@ -2387,14 +2807,14 @@
       </p:sp>
       <p:sp>
         <p:nvSpPr>
-          <p:cNvPr id="33" name="Shape 31"/>
-          <p:cNvSpPr/>
-          <p:nvPr/>
-        </p:nvSpPr>
-        <p:spPr>
-          <a:xfrm>
-            <a:off x="7240219" y="4297680"/>
-            <a:ext cx="0" cy="1956816"/>
+          <p:cNvPr id="48" name="Shape 45"/>
+          <p:cNvSpPr/>
+          <p:nvPr/>
+        </p:nvSpPr>
+        <p:spPr>
+          <a:xfrm>
+            <a:off x="7240219" y="4361688"/>
+            <a:ext cx="0" cy="1764792"/>
           </a:xfrm>
           <a:prstGeom prst="line">
             <a:avLst/>
@@ -2402,7 +2822,7 @@
           <a:noFill/>
           <a:ln w="9525">
             <a:solidFill>
-              <a:srgbClr val="D9D9D9"/>
+              <a:srgbClr val="E3E6ED"/>
             </a:solidFill>
             <a:prstDash val="solid"/>
           </a:ln>
@@ -2410,14 +2830,14 @@
       </p:sp>
       <p:sp>
         <p:nvSpPr>
-          <p:cNvPr id="34" name="Shape 32"/>
-          <p:cNvSpPr/>
-          <p:nvPr/>
-        </p:nvSpPr>
-        <p:spPr>
-          <a:xfrm>
-            <a:off x="9531706" y="4297680"/>
-            <a:ext cx="0" cy="1956816"/>
+          <p:cNvPr id="49" name="Shape 46"/>
+          <p:cNvSpPr/>
+          <p:nvPr/>
+        </p:nvSpPr>
+        <p:spPr>
+          <a:xfrm>
+            <a:off x="9531706" y="4361688"/>
+            <a:ext cx="0" cy="1764792"/>
           </a:xfrm>
           <a:prstGeom prst="line">
             <a:avLst/>
@@ -2425,7 +2845,7 @@
           <a:noFill/>
           <a:ln w="9525">
             <a:solidFill>
-              <a:srgbClr val="D9D9D9"/>
+              <a:srgbClr val="E3E6ED"/>
             </a:solidFill>
             <a:prstDash val="solid"/>
           </a:ln>
@@ -2433,14 +2853,14 @@
       </p:sp>
       <p:sp>
         <p:nvSpPr>
-          <p:cNvPr id="35" name="Text 33"/>
-          <p:cNvSpPr/>
-          <p:nvPr/>
-        </p:nvSpPr>
-        <p:spPr>
-          <a:xfrm>
-            <a:off x="475488" y="4297680"/>
-            <a:ext cx="2072030" cy="1975104"/>
+          <p:cNvPr id="50" name="Text 47"/>
+          <p:cNvSpPr/>
+          <p:nvPr/>
+        </p:nvSpPr>
+        <p:spPr>
+          <a:xfrm>
+            <a:off x="475488" y="4361688"/>
+            <a:ext cx="2072030" cy="1783080"/>
           </a:xfrm>
           <a:prstGeom prst="rect">
             <a:avLst/>
@@ -2454,291 +2874,291 @@
           <a:p>
             <a:pPr indent="0" marL="0">
               <a:spcAft>
-                <a:spcPts val="500"/>
-              </a:spcAft>
-              <a:buNone/>
-            </a:pPr>
-            <a:r>
-              <a:rPr lang="en-US" sz="860" dirty="0">
-                <a:solidFill>
-                  <a:srgbClr val="404040"/>
-                </a:solidFill>
-                <a:latin typeface="Segoe UI" pitchFamily="34" charset="0"/>
-                <a:ea typeface="Segoe UI" pitchFamily="34" charset="-122"/>
-                <a:cs typeface="Segoe UI" pitchFamily="34" charset="-120"/>
+                <a:spcPts val="300"/>
+              </a:spcAft>
+              <a:buNone/>
+            </a:pPr>
+            <a:r>
+              <a:rPr lang="en-US" sz="800" dirty="0">
+                <a:solidFill>
+                  <a:srgbClr val="47494E"/>
+                </a:solidFill>
+                <a:latin typeface="Aptos" pitchFamily="34" charset="0"/>
+                <a:ea typeface="Aptos" pitchFamily="34" charset="-122"/>
+                <a:cs typeface="Aptos" pitchFamily="34" charset="-120"/>
               </a:rPr>
               <a:t>Federate a </a:t>
             </a:r>
             <a:pPr indent="0" marL="0">
               <a:spcAft>
-                <a:spcPts val="500"/>
-              </a:spcAft>
-              <a:buNone/>
-            </a:pPr>
-            <a:r>
-              <a:rPr lang="en-US" sz="860" b="1" dirty="0">
-                <a:solidFill>
-                  <a:srgbClr val="404040"/>
-                </a:solidFill>
-                <a:latin typeface="Segoe UI" pitchFamily="34" charset="0"/>
-                <a:ea typeface="Segoe UI" pitchFamily="34" charset="-122"/>
-                <a:cs typeface="Segoe UI" pitchFamily="34" charset="-120"/>
+                <a:spcPts val="300"/>
+              </a:spcAft>
+              <a:buNone/>
+            </a:pPr>
+            <a:r>
+              <a:rPr lang="en-US" sz="800" b="1" dirty="0">
+                <a:solidFill>
+                  <a:srgbClr val="032254"/>
+                </a:solidFill>
+                <a:latin typeface="Aptos" pitchFamily="34" charset="0"/>
+                <a:ea typeface="Aptos" pitchFamily="34" charset="-122"/>
+                <a:cs typeface="Aptos" pitchFamily="34" charset="-120"/>
               </a:rPr>
               <a:t>service principal</a:t>
             </a:r>
             <a:pPr indent="0" marL="0">
               <a:spcAft>
-                <a:spcPts val="500"/>
-              </a:spcAft>
-              <a:buNone/>
-            </a:pPr>
-            <a:r>
-              <a:rPr lang="en-US" sz="860" dirty="0">
-                <a:solidFill>
-                  <a:srgbClr val="404040"/>
-                </a:solidFill>
-                <a:latin typeface="Segoe UI" pitchFamily="34" charset="0"/>
-                <a:ea typeface="Segoe UI" pitchFamily="34" charset="-122"/>
-                <a:cs typeface="Segoe UI" pitchFamily="34" charset="-120"/>
+                <a:spcPts val="300"/>
+              </a:spcAft>
+              <a:buNone/>
+            </a:pPr>
+            <a:r>
+              <a:rPr lang="en-US" sz="800" dirty="0">
+                <a:solidFill>
+                  <a:srgbClr val="47494E"/>
+                </a:solidFill>
+                <a:latin typeface="Aptos" pitchFamily="34" charset="0"/>
+                <a:ea typeface="Aptos" pitchFamily="34" charset="-122"/>
+                <a:cs typeface="Aptos" pitchFamily="34" charset="-120"/>
               </a:rPr>
               <a:t> to GitHub via </a:t>
             </a:r>
             <a:pPr indent="0" marL="0">
               <a:spcAft>
-                <a:spcPts val="500"/>
-              </a:spcAft>
-              <a:buNone/>
-            </a:pPr>
-            <a:r>
-              <a:rPr lang="en-US" sz="860" b="1" dirty="0">
-                <a:solidFill>
-                  <a:srgbClr val="404040"/>
-                </a:solidFill>
-                <a:latin typeface="Segoe UI" pitchFamily="34" charset="0"/>
-                <a:ea typeface="Segoe UI" pitchFamily="34" charset="-122"/>
-                <a:cs typeface="Segoe UI" pitchFamily="34" charset="-120"/>
+                <a:spcPts val="300"/>
+              </a:spcAft>
+              <a:buNone/>
+            </a:pPr>
+            <a:r>
+              <a:rPr lang="en-US" sz="800" b="1" dirty="0">
+                <a:solidFill>
+                  <a:srgbClr val="032254"/>
+                </a:solidFill>
+                <a:latin typeface="Aptos" pitchFamily="34" charset="0"/>
+                <a:ea typeface="Aptos" pitchFamily="34" charset="-122"/>
+                <a:cs typeface="Aptos" pitchFamily="34" charset="-120"/>
               </a:rPr>
               <a:t>OIDC</a:t>
             </a:r>
             <a:pPr indent="0" marL="0">
               <a:spcAft>
-                <a:spcPts val="500"/>
-              </a:spcAft>
-              <a:buNone/>
-            </a:pPr>
-            <a:r>
-              <a:rPr lang="en-US" sz="860" dirty="0">
-                <a:solidFill>
-                  <a:srgbClr val="404040"/>
-                </a:solidFill>
-                <a:latin typeface="Segoe UI" pitchFamily="34" charset="0"/>
-                <a:ea typeface="Segoe UI" pitchFamily="34" charset="-122"/>
-                <a:cs typeface="Segoe UI" pitchFamily="34" charset="-120"/>
+                <a:spcPts val="300"/>
+              </a:spcAft>
+              <a:buNone/>
+            </a:pPr>
+            <a:r>
+              <a:rPr lang="en-US" sz="800" dirty="0">
+                <a:solidFill>
+                  <a:srgbClr val="47494E"/>
+                </a:solidFill>
+                <a:latin typeface="Aptos" pitchFamily="34" charset="0"/>
+                <a:ea typeface="Aptos" pitchFamily="34" charset="-122"/>
+                <a:cs typeface="Aptos" pitchFamily="34" charset="-120"/>
               </a:rPr>
               <a:t> — zero secrets</a:t>
             </a:r>
-            <a:endParaRPr lang="en-US" sz="860" dirty="0"/>
-          </a:p>
-          <a:p>
-            <a:pPr indent="0" marL="0">
-              <a:spcAft>
-                <a:spcPts val="500"/>
-              </a:spcAft>
-              <a:buNone/>
-            </a:pPr>
-            <a:r>
-              <a:rPr lang="en-US" sz="860" dirty="0">
-                <a:solidFill>
-                  <a:srgbClr val="404040"/>
-                </a:solidFill>
-                <a:latin typeface="Segoe UI" pitchFamily="34" charset="0"/>
-                <a:ea typeface="Segoe UI" pitchFamily="34" charset="-122"/>
-                <a:cs typeface="Segoe UI" pitchFamily="34" charset="-120"/>
+            <a:endParaRPr lang="en-US" sz="800" dirty="0"/>
+          </a:p>
+          <a:p>
+            <a:pPr indent="0" marL="0">
+              <a:spcAft>
+                <a:spcPts val="300"/>
+              </a:spcAft>
+              <a:buNone/>
+            </a:pPr>
+            <a:r>
+              <a:rPr lang="en-US" sz="800" dirty="0">
+                <a:solidFill>
+                  <a:srgbClr val="47494E"/>
+                </a:solidFill>
+                <a:latin typeface="Aptos" pitchFamily="34" charset="0"/>
+                <a:ea typeface="Aptos" pitchFamily="34" charset="-122"/>
+                <a:cs typeface="Aptos" pitchFamily="34" charset="-120"/>
               </a:rPr>
               <a:t>Install + verify </a:t>
             </a:r>
             <a:pPr indent="0" marL="0">
               <a:spcAft>
-                <a:spcPts val="500"/>
-              </a:spcAft>
-              <a:buNone/>
-            </a:pPr>
-            <a:r>
-              <a:rPr lang="en-US" sz="860" b="1" dirty="0">
-                <a:solidFill>
-                  <a:srgbClr val="404040"/>
-                </a:solidFill>
-                <a:latin typeface="Segoe UI" pitchFamily="34" charset="0"/>
-                <a:ea typeface="Segoe UI" pitchFamily="34" charset="-122"/>
-                <a:cs typeface="Segoe UI" pitchFamily="34" charset="-120"/>
+                <a:spcPts val="300"/>
+              </a:spcAft>
+              <a:buNone/>
+            </a:pPr>
+            <a:r>
+              <a:rPr lang="en-US" sz="800" b="1" dirty="0">
+                <a:solidFill>
+                  <a:srgbClr val="032254"/>
+                </a:solidFill>
+                <a:latin typeface="Aptos" pitchFamily="34" charset="0"/>
+                <a:ea typeface="Aptos" pitchFamily="34" charset="-122"/>
+                <a:cs typeface="Aptos" pitchFamily="34" charset="-120"/>
               </a:rPr>
               <a:t>Fabric MCP</a:t>
             </a:r>
             <a:pPr indent="0" marL="0">
               <a:spcAft>
-                <a:spcPts val="500"/>
-              </a:spcAft>
-              <a:buNone/>
-            </a:pPr>
-            <a:r>
-              <a:rPr lang="en-US" sz="860" dirty="0">
-                <a:solidFill>
-                  <a:srgbClr val="404040"/>
-                </a:solidFill>
-                <a:latin typeface="Segoe UI" pitchFamily="34" charset="0"/>
-                <a:ea typeface="Segoe UI" pitchFamily="34" charset="-122"/>
-                <a:cs typeface="Segoe UI" pitchFamily="34" charset="-120"/>
+                <a:spcPts val="300"/>
+              </a:spcAft>
+              <a:buNone/>
+            </a:pPr>
+            <a:r>
+              <a:rPr lang="en-US" sz="800" dirty="0">
+                <a:solidFill>
+                  <a:srgbClr val="47494E"/>
+                </a:solidFill>
+                <a:latin typeface="Aptos" pitchFamily="34" charset="0"/>
+                <a:ea typeface="Aptos" pitchFamily="34" charset="-122"/>
+                <a:cs typeface="Aptos" pitchFamily="34" charset="-120"/>
               </a:rPr>
               <a:t> servers and </a:t>
             </a:r>
             <a:pPr indent="0" marL="0">
               <a:spcAft>
-                <a:spcPts val="500"/>
-              </a:spcAft>
-              <a:buNone/>
-            </a:pPr>
-            <a:r>
-              <a:rPr lang="en-US" sz="860" b="1" dirty="0">
-                <a:solidFill>
-                  <a:srgbClr val="404040"/>
-                </a:solidFill>
-                <a:latin typeface="Segoe UI" pitchFamily="34" charset="0"/>
-                <a:ea typeface="Segoe UI" pitchFamily="34" charset="-122"/>
-                <a:cs typeface="Segoe UI" pitchFamily="34" charset="-120"/>
+                <a:spcPts val="300"/>
+              </a:spcAft>
+              <a:buNone/>
+            </a:pPr>
+            <a:r>
+              <a:rPr lang="en-US" sz="800" b="1" dirty="0">
+                <a:solidFill>
+                  <a:srgbClr val="032254"/>
+                </a:solidFill>
+                <a:latin typeface="Aptos" pitchFamily="34" charset="0"/>
+                <a:ea typeface="Aptos" pitchFamily="34" charset="-122"/>
+                <a:cs typeface="Aptos" pitchFamily="34" charset="-120"/>
               </a:rPr>
               <a:t>Skills for Fabric</a:t>
             </a:r>
-            <a:endParaRPr lang="en-US" sz="860" dirty="0"/>
-          </a:p>
-          <a:p>
-            <a:pPr indent="0" marL="0">
-              <a:spcAft>
-                <a:spcPts val="500"/>
-              </a:spcAft>
-              <a:buNone/>
-            </a:pPr>
-            <a:r>
-              <a:rPr lang="en-US" sz="860" dirty="0">
-                <a:solidFill>
-                  <a:srgbClr val="404040"/>
-                </a:solidFill>
-                <a:latin typeface="Segoe UI" pitchFamily="34" charset="0"/>
-                <a:ea typeface="Segoe UI" pitchFamily="34" charset="-122"/>
-                <a:cs typeface="Segoe UI" pitchFamily="34" charset="-120"/>
+            <a:endParaRPr lang="en-US" sz="800" dirty="0"/>
+          </a:p>
+          <a:p>
+            <a:pPr indent="0" marL="0">
+              <a:spcAft>
+                <a:spcPts val="300"/>
+              </a:spcAft>
+              <a:buNone/>
+            </a:pPr>
+            <a:r>
+              <a:rPr lang="en-US" sz="800" dirty="0">
+                <a:solidFill>
+                  <a:srgbClr val="47494E"/>
+                </a:solidFill>
+                <a:latin typeface="Aptos" pitchFamily="34" charset="0"/>
+                <a:ea typeface="Aptos" pitchFamily="34" charset="-122"/>
+                <a:cs typeface="Aptos" pitchFamily="34" charset="-120"/>
               </a:rPr>
               <a:t>Toggle tenant settings; smoke-test agent prompts</a:t>
             </a:r>
-            <a:endParaRPr lang="en-US" sz="860" dirty="0"/>
-          </a:p>
-          <a:p>
-            <a:pPr indent="0" marL="0">
-              <a:spcAft>
-                <a:spcPts val="500"/>
-              </a:spcAft>
-              <a:buNone/>
-            </a:pPr>
-            <a:r>
-              <a:rPr lang="en-US" sz="600" dirty="0">
-                <a:solidFill>
-                  <a:srgbClr val="404040"/>
-                </a:solidFill>
-                <a:latin typeface="Segoe UI" pitchFamily="34" charset="0"/>
-                <a:ea typeface="Segoe UI" pitchFamily="34" charset="-122"/>
-                <a:cs typeface="Segoe UI" pitchFamily="34" charset="-120"/>
+            <a:endParaRPr lang="en-US" sz="800" dirty="0"/>
+          </a:p>
+          <a:p>
+            <a:pPr indent="0" marL="0">
+              <a:spcAft>
+                <a:spcPts val="300"/>
+              </a:spcAft>
+              <a:buNone/>
+            </a:pPr>
+            <a:r>
+              <a:rPr lang="en-US" sz="300" dirty="0">
+                <a:solidFill>
+                  <a:srgbClr val="47494E"/>
+                </a:solidFill>
+                <a:latin typeface="Aptos" pitchFamily="34" charset="0"/>
+                <a:ea typeface="Aptos" pitchFamily="34" charset="-122"/>
+                <a:cs typeface="Aptos" pitchFamily="34" charset="-120"/>
               </a:rPr>
               <a:t> </a:t>
             </a:r>
-            <a:endParaRPr lang="en-US" sz="860" dirty="0"/>
-          </a:p>
-          <a:p>
-            <a:pPr indent="0" marL="0">
-              <a:spcAft>
-                <a:spcPts val="500"/>
+            <a:endParaRPr lang="en-US" sz="800" dirty="0"/>
+          </a:p>
+          <a:p>
+            <a:pPr indent="0" marL="0">
+              <a:spcAft>
+                <a:spcPts val="300"/>
               </a:spcAft>
               <a:buNone/>
             </a:pPr>
             <a:r>
               <a:rPr lang="en-US" sz="750" b="1" spc="100" kern="0" dirty="0">
                 <a:solidFill>
-                  <a:srgbClr val="808080"/>
-                </a:solidFill>
-                <a:latin typeface="Segoe UI" pitchFamily="34" charset="0"/>
-                <a:ea typeface="Segoe UI" pitchFamily="34" charset="-122"/>
-                <a:cs typeface="Segoe UI" pitchFamily="34" charset="-120"/>
+                  <a:srgbClr val="6B7280"/>
+                </a:solidFill>
+                <a:latin typeface="Aptos" pitchFamily="34" charset="0"/>
+                <a:ea typeface="Aptos" pitchFamily="34" charset="-122"/>
+                <a:cs typeface="Aptos" pitchFamily="34" charset="-120"/>
               </a:rPr>
               <a:t>OUTPUT</a:t>
             </a:r>
-            <a:endParaRPr lang="en-US" sz="860" dirty="0"/>
-          </a:p>
-          <a:p>
-            <a:pPr indent="0" marL="0">
-              <a:spcAft>
-                <a:spcPts val="500"/>
-              </a:spcAft>
-              <a:buNone/>
-            </a:pPr>
-            <a:r>
-              <a:rPr lang="en-US" sz="860" b="1" dirty="0">
-                <a:solidFill>
-                  <a:srgbClr val="404040"/>
-                </a:solidFill>
-                <a:latin typeface="Segoe UI" pitchFamily="34" charset="0"/>
-                <a:ea typeface="Segoe UI" pitchFamily="34" charset="-122"/>
-                <a:cs typeface="Segoe UI" pitchFamily="34" charset="-120"/>
-              </a:rPr>
-              <a:t>Hackathon-ready tenant</a:t>
-            </a:r>
-            <a:pPr indent="0" marL="0">
-              <a:spcAft>
-                <a:spcPts val="500"/>
-              </a:spcAft>
-              <a:buNone/>
-            </a:pPr>
-            <a:r>
-              <a:rPr lang="en-US" sz="860" dirty="0">
-                <a:solidFill>
-                  <a:srgbClr val="404040"/>
-                </a:solidFill>
-                <a:latin typeface="Segoe UI" pitchFamily="34" charset="0"/>
-                <a:ea typeface="Segoe UI" pitchFamily="34" charset="-122"/>
-                <a:cs typeface="Segoe UI" pitchFamily="34" charset="-120"/>
+            <a:endParaRPr lang="en-US" sz="800" dirty="0"/>
+          </a:p>
+          <a:p>
+            <a:pPr indent="0" marL="0">
+              <a:spcAft>
+                <a:spcPts val="300"/>
+              </a:spcAft>
+              <a:buNone/>
+            </a:pPr>
+            <a:r>
+              <a:rPr lang="en-US" sz="800" b="1" dirty="0">
+                <a:solidFill>
+                  <a:srgbClr val="032254"/>
+                </a:solidFill>
+                <a:latin typeface="Aptos" pitchFamily="34" charset="0"/>
+                <a:ea typeface="Aptos" pitchFamily="34" charset="-122"/>
+                <a:cs typeface="Aptos" pitchFamily="34" charset="-120"/>
+              </a:rPr>
+              <a:t>RVAS-ready tenant</a:t>
+            </a:r>
+            <a:pPr indent="0" marL="0">
+              <a:spcAft>
+                <a:spcPts val="300"/>
+              </a:spcAft>
+              <a:buNone/>
+            </a:pPr>
+            <a:r>
+              <a:rPr lang="en-US" sz="800" dirty="0">
+                <a:solidFill>
+                  <a:srgbClr val="47494E"/>
+                </a:solidFill>
+                <a:latin typeface="Aptos" pitchFamily="34" charset="0"/>
+                <a:ea typeface="Aptos" pitchFamily="34" charset="-122"/>
+                <a:cs typeface="Aptos" pitchFamily="34" charset="-120"/>
               </a:rPr>
               <a:t> + identity auditors can defend</a:t>
             </a:r>
-            <a:endParaRPr lang="en-US" sz="860" dirty="0"/>
-          </a:p>
-          <a:p>
-            <a:pPr indent="0" marL="0">
-              <a:spcAft>
-                <a:spcPts val="500"/>
+            <a:endParaRPr lang="en-US" sz="800" dirty="0"/>
+          </a:p>
+          <a:p>
+            <a:pPr indent="0" marL="0">
+              <a:spcAft>
+                <a:spcPts val="300"/>
               </a:spcAft>
               <a:buNone/>
             </a:pPr>
             <a:r>
               <a:rPr lang="en-US" sz="750" i="1" dirty="0">
                 <a:solidFill>
-                  <a:srgbClr val="A6A6A6"/>
-                </a:solidFill>
-                <a:latin typeface="Segoe UI" pitchFamily="34" charset="0"/>
-                <a:ea typeface="Segoe UI" pitchFamily="34" charset="-122"/>
-                <a:cs typeface="Segoe UI" pitchFamily="34" charset="-120"/>
+                  <a:srgbClr val="6B7280"/>
+                </a:solidFill>
+                <a:latin typeface="Aptos" pitchFamily="34" charset="0"/>
+                <a:ea typeface="Aptos" pitchFamily="34" charset="-122"/>
+                <a:cs typeface="Aptos" pitchFamily="34" charset="-120"/>
               </a:rPr>
               <a:t>Challenge 00</a:t>
             </a:r>
-            <a:endParaRPr lang="en-US" sz="860" dirty="0"/>
+            <a:endParaRPr lang="en-US" sz="800" dirty="0"/>
           </a:p>
         </p:txBody>
       </p:sp>
       <p:sp>
         <p:nvSpPr>
-          <p:cNvPr id="36" name="Text 34"/>
-          <p:cNvSpPr/>
-          <p:nvPr/>
-        </p:nvSpPr>
-        <p:spPr>
-          <a:xfrm>
-            <a:off x="2766974" y="4297680"/>
-            <a:ext cx="2072030" cy="1975104"/>
+          <p:cNvPr id="51" name="Text 48"/>
+          <p:cNvSpPr/>
+          <p:nvPr/>
+        </p:nvSpPr>
+        <p:spPr>
+          <a:xfrm>
+            <a:off x="2766974" y="4361688"/>
+            <a:ext cx="2072030" cy="1783080"/>
           </a:xfrm>
           <a:prstGeom prst="rect">
             <a:avLst/>
@@ -2752,189 +3172,189 @@
           <a:p>
             <a:pPr indent="0" marL="0">
               <a:spcAft>
-                <a:spcPts val="500"/>
-              </a:spcAft>
-              <a:buNone/>
-            </a:pPr>
-            <a:r>
-              <a:rPr lang="en-US" sz="860" dirty="0">
-                <a:solidFill>
-                  <a:srgbClr val="404040"/>
-                </a:solidFill>
-                <a:latin typeface="Segoe UI" pitchFamily="34" charset="0"/>
-                <a:ea typeface="Segoe UI" pitchFamily="34" charset="-122"/>
-                <a:cs typeface="Segoe UI" pitchFamily="34" charset="-120"/>
+                <a:spcPts val="300"/>
+              </a:spcAft>
+              <a:buNone/>
+            </a:pPr>
+            <a:r>
+              <a:rPr lang="en-US" sz="800" dirty="0">
+                <a:solidFill>
+                  <a:srgbClr val="47494E"/>
+                </a:solidFill>
+                <a:latin typeface="Aptos" pitchFamily="34" charset="0"/>
+                <a:ea typeface="Aptos" pitchFamily="34" charset="-122"/>
+                <a:cs typeface="Aptos" pitchFamily="34" charset="-120"/>
               </a:rPr>
               <a:t>Workspaces created, updated, decommissioned </a:t>
             </a:r>
             <a:pPr indent="0" marL="0">
               <a:spcAft>
-                <a:spcPts val="500"/>
-              </a:spcAft>
-              <a:buNone/>
-            </a:pPr>
-            <a:r>
-              <a:rPr lang="en-US" sz="860" b="1" dirty="0">
-                <a:solidFill>
-                  <a:srgbClr val="404040"/>
-                </a:solidFill>
-                <a:latin typeface="Segoe UI" pitchFamily="34" charset="0"/>
-                <a:ea typeface="Segoe UI" pitchFamily="34" charset="-122"/>
-                <a:cs typeface="Segoe UI" pitchFamily="34" charset="-120"/>
+                <a:spcPts val="300"/>
+              </a:spcAft>
+              <a:buNone/>
+            </a:pPr>
+            <a:r>
+              <a:rPr lang="en-US" sz="800" b="1" dirty="0">
+                <a:solidFill>
+                  <a:srgbClr val="032254"/>
+                </a:solidFill>
+                <a:latin typeface="Aptos" pitchFamily="34" charset="0"/>
+                <a:ea typeface="Aptos" pitchFamily="34" charset="-122"/>
+                <a:cs typeface="Aptos" pitchFamily="34" charset="-120"/>
               </a:rPr>
               <a:t>only via Pull Request</a:t>
             </a:r>
-            <a:endParaRPr lang="en-US" sz="860" dirty="0"/>
-          </a:p>
-          <a:p>
-            <a:pPr indent="0" marL="0">
-              <a:spcAft>
-                <a:spcPts val="500"/>
-              </a:spcAft>
-              <a:buNone/>
-            </a:pPr>
-            <a:r>
-              <a:rPr lang="en-US" sz="860" b="1" dirty="0">
-                <a:solidFill>
-                  <a:srgbClr val="404040"/>
-                </a:solidFill>
-                <a:latin typeface="Segoe UI" pitchFamily="34" charset="0"/>
-                <a:ea typeface="Segoe UI" pitchFamily="34" charset="-122"/>
-                <a:cs typeface="Segoe UI" pitchFamily="34" charset="-120"/>
+            <a:endParaRPr lang="en-US" sz="800" dirty="0"/>
+          </a:p>
+          <a:p>
+            <a:pPr indent="0" marL="0">
+              <a:spcAft>
+                <a:spcPts val="300"/>
+              </a:spcAft>
+              <a:buNone/>
+            </a:pPr>
+            <a:r>
+              <a:rPr lang="en-US" sz="800" b="1" dirty="0">
+                <a:solidFill>
+                  <a:srgbClr val="032254"/>
+                </a:solidFill>
+                <a:latin typeface="Aptos" pitchFamily="34" charset="0"/>
+                <a:ea typeface="Aptos" pitchFamily="34" charset="-122"/>
+                <a:cs typeface="Aptos" pitchFamily="34" charset="-120"/>
               </a:rPr>
               <a:t>PR → validate → OIDC provision → nightly drift</a:t>
             </a:r>
-            <a:endParaRPr lang="en-US" sz="860" dirty="0"/>
-          </a:p>
-          <a:p>
-            <a:pPr indent="0" marL="0">
-              <a:spcAft>
-                <a:spcPts val="500"/>
-              </a:spcAft>
-              <a:buNone/>
-            </a:pPr>
-            <a:r>
-              <a:rPr lang="en-US" sz="860" dirty="0">
-                <a:solidFill>
-                  <a:srgbClr val="404040"/>
-                </a:solidFill>
-                <a:latin typeface="Segoe UI" pitchFamily="34" charset="0"/>
-                <a:ea typeface="Segoe UI" pitchFamily="34" charset="-122"/>
-                <a:cs typeface="Segoe UI" pitchFamily="34" charset="-120"/>
+            <a:endParaRPr lang="en-US" sz="800" dirty="0"/>
+          </a:p>
+          <a:p>
+            <a:pPr indent="0" marL="0">
+              <a:spcAft>
+                <a:spcPts val="300"/>
+              </a:spcAft>
+              <a:buNone/>
+            </a:pPr>
+            <a:r>
+              <a:rPr lang="en-US" sz="800" dirty="0">
+                <a:solidFill>
+                  <a:srgbClr val="47494E"/>
+                </a:solidFill>
+                <a:latin typeface="Aptos" pitchFamily="34" charset="0"/>
+                <a:ea typeface="Aptos" pitchFamily="34" charset="-122"/>
+                <a:cs typeface="Aptos" pitchFamily="34" charset="-120"/>
               </a:rPr>
               <a:t>Same validator runs locally and in CI</a:t>
             </a:r>
-            <a:endParaRPr lang="en-US" sz="860" dirty="0"/>
-          </a:p>
-          <a:p>
-            <a:pPr indent="0" marL="0">
-              <a:spcAft>
-                <a:spcPts val="500"/>
-              </a:spcAft>
-              <a:buNone/>
-            </a:pPr>
-            <a:r>
-              <a:rPr lang="en-US" sz="600" dirty="0">
-                <a:solidFill>
-                  <a:srgbClr val="404040"/>
-                </a:solidFill>
-                <a:latin typeface="Segoe UI" pitchFamily="34" charset="0"/>
-                <a:ea typeface="Segoe UI" pitchFamily="34" charset="-122"/>
-                <a:cs typeface="Segoe UI" pitchFamily="34" charset="-120"/>
+            <a:endParaRPr lang="en-US" sz="800" dirty="0"/>
+          </a:p>
+          <a:p>
+            <a:pPr indent="0" marL="0">
+              <a:spcAft>
+                <a:spcPts val="300"/>
+              </a:spcAft>
+              <a:buNone/>
+            </a:pPr>
+            <a:r>
+              <a:rPr lang="en-US" sz="300" dirty="0">
+                <a:solidFill>
+                  <a:srgbClr val="47494E"/>
+                </a:solidFill>
+                <a:latin typeface="Aptos" pitchFamily="34" charset="0"/>
+                <a:ea typeface="Aptos" pitchFamily="34" charset="-122"/>
+                <a:cs typeface="Aptos" pitchFamily="34" charset="-120"/>
               </a:rPr>
               <a:t> </a:t>
             </a:r>
-            <a:endParaRPr lang="en-US" sz="860" dirty="0"/>
-          </a:p>
-          <a:p>
-            <a:pPr indent="0" marL="0">
-              <a:spcAft>
-                <a:spcPts val="500"/>
+            <a:endParaRPr lang="en-US" sz="800" dirty="0"/>
+          </a:p>
+          <a:p>
+            <a:pPr indent="0" marL="0">
+              <a:spcAft>
+                <a:spcPts val="300"/>
               </a:spcAft>
               <a:buNone/>
             </a:pPr>
             <a:r>
               <a:rPr lang="en-US" sz="750" b="1" spc="100" kern="0" dirty="0">
                 <a:solidFill>
-                  <a:srgbClr val="808080"/>
-                </a:solidFill>
-                <a:latin typeface="Segoe UI" pitchFamily="34" charset="0"/>
-                <a:ea typeface="Segoe UI" pitchFamily="34" charset="-122"/>
-                <a:cs typeface="Segoe UI" pitchFamily="34" charset="-120"/>
+                  <a:srgbClr val="6B7280"/>
+                </a:solidFill>
+                <a:latin typeface="Aptos" pitchFamily="34" charset="0"/>
+                <a:ea typeface="Aptos" pitchFamily="34" charset="-122"/>
+                <a:cs typeface="Aptos" pitchFamily="34" charset="-120"/>
               </a:rPr>
               <a:t>OUTPUT</a:t>
             </a:r>
-            <a:endParaRPr lang="en-US" sz="860" dirty="0"/>
-          </a:p>
-          <a:p>
-            <a:pPr indent="0" marL="0">
-              <a:spcAft>
-                <a:spcPts val="500"/>
-              </a:spcAft>
-              <a:buNone/>
-            </a:pPr>
-            <a:r>
-              <a:rPr lang="en-US" sz="860" b="1" dirty="0">
-                <a:solidFill>
-                  <a:srgbClr val="404040"/>
-                </a:solidFill>
-                <a:latin typeface="Segoe UI" pitchFamily="34" charset="0"/>
-                <a:ea typeface="Segoe UI" pitchFamily="34" charset="-122"/>
-                <a:cs typeface="Segoe UI" pitchFamily="34" charset="-120"/>
+            <a:endParaRPr lang="en-US" sz="800" dirty="0"/>
+          </a:p>
+          <a:p>
+            <a:pPr indent="0" marL="0">
+              <a:spcAft>
+                <a:spcPts val="300"/>
+              </a:spcAft>
+              <a:buNone/>
+            </a:pPr>
+            <a:r>
+              <a:rPr lang="en-US" sz="800" b="1" dirty="0">
+                <a:solidFill>
+                  <a:srgbClr val="032254"/>
+                </a:solidFill>
+                <a:latin typeface="Aptos" pitchFamily="34" charset="0"/>
+                <a:ea typeface="Aptos" pitchFamily="34" charset="-122"/>
+                <a:cs typeface="Aptos" pitchFamily="34" charset="-120"/>
               </a:rPr>
               <a:t>Auditable workspace lifecycle</a:t>
             </a:r>
             <a:pPr indent="0" marL="0">
               <a:spcAft>
-                <a:spcPts val="500"/>
-              </a:spcAft>
-              <a:buNone/>
-            </a:pPr>
-            <a:r>
-              <a:rPr lang="en-US" sz="860" dirty="0">
-                <a:solidFill>
-                  <a:srgbClr val="404040"/>
-                </a:solidFill>
-                <a:latin typeface="Segoe UI" pitchFamily="34" charset="0"/>
-                <a:ea typeface="Segoe UI" pitchFamily="34" charset="-122"/>
-                <a:cs typeface="Segoe UI" pitchFamily="34" charset="-120"/>
+                <a:spcPts val="300"/>
+              </a:spcAft>
+              <a:buNone/>
+            </a:pPr>
+            <a:r>
+              <a:rPr lang="en-US" sz="800" dirty="0">
+                <a:solidFill>
+                  <a:srgbClr val="47494E"/>
+                </a:solidFill>
+                <a:latin typeface="Aptos" pitchFamily="34" charset="0"/>
+                <a:ea typeface="Aptos" pitchFamily="34" charset="-122"/>
+                <a:cs typeface="Aptos" pitchFamily="34" charset="-120"/>
               </a:rPr>
               <a:t>; provable “no ClickOps”</a:t>
             </a:r>
-            <a:endParaRPr lang="en-US" sz="860" dirty="0"/>
-          </a:p>
-          <a:p>
-            <a:pPr indent="0" marL="0">
-              <a:spcAft>
-                <a:spcPts val="500"/>
+            <a:endParaRPr lang="en-US" sz="800" dirty="0"/>
+          </a:p>
+          <a:p>
+            <a:pPr indent="0" marL="0">
+              <a:spcAft>
+                <a:spcPts val="300"/>
               </a:spcAft>
               <a:buNone/>
             </a:pPr>
             <a:r>
               <a:rPr lang="en-US" sz="750" i="1" dirty="0">
                 <a:solidFill>
-                  <a:srgbClr val="A6A6A6"/>
-                </a:solidFill>
-                <a:latin typeface="Segoe UI" pitchFamily="34" charset="0"/>
-                <a:ea typeface="Segoe UI" pitchFamily="34" charset="-122"/>
-                <a:cs typeface="Segoe UI" pitchFamily="34" charset="-120"/>
+                  <a:srgbClr val="6B7280"/>
+                </a:solidFill>
+                <a:latin typeface="Aptos" pitchFamily="34" charset="0"/>
+                <a:ea typeface="Aptos" pitchFamily="34" charset="-122"/>
+                <a:cs typeface="Aptos" pitchFamily="34" charset="-120"/>
               </a:rPr>
               <a:t>Challenge 01</a:t>
             </a:r>
-            <a:endParaRPr lang="en-US" sz="860" dirty="0"/>
+            <a:endParaRPr lang="en-US" sz="800" dirty="0"/>
           </a:p>
         </p:txBody>
       </p:sp>
       <p:sp>
         <p:nvSpPr>
-          <p:cNvPr id="37" name="Text 35"/>
-          <p:cNvSpPr/>
-          <p:nvPr/>
-        </p:nvSpPr>
-        <p:spPr>
-          <a:xfrm>
-            <a:off x="5058461" y="4297680"/>
-            <a:ext cx="2072030" cy="1975104"/>
+          <p:cNvPr id="52" name="Text 49"/>
+          <p:cNvSpPr/>
+          <p:nvPr/>
+        </p:nvSpPr>
+        <p:spPr>
+          <a:xfrm>
+            <a:off x="5058461" y="4361688"/>
+            <a:ext cx="2072030" cy="1783080"/>
           </a:xfrm>
           <a:prstGeom prst="rect">
             <a:avLst/>
@@ -2948,223 +3368,223 @@
           <a:p>
             <a:pPr indent="0" marL="0">
               <a:spcAft>
-                <a:spcPts val="500"/>
-              </a:spcAft>
-              <a:buNone/>
-            </a:pPr>
-            <a:r>
-              <a:rPr lang="en-US" sz="860" b="1" dirty="0">
-                <a:solidFill>
-                  <a:srgbClr val="404040"/>
-                </a:solidFill>
-                <a:latin typeface="Segoe UI" pitchFamily="34" charset="0"/>
-                <a:ea typeface="Segoe UI" pitchFamily="34" charset="-122"/>
-                <a:cs typeface="Segoe UI" pitchFamily="34" charset="-120"/>
+                <a:spcPts val="300"/>
+              </a:spcAft>
+              <a:buNone/>
+            </a:pPr>
+            <a:r>
+              <a:rPr lang="en-US" sz="800" b="1" dirty="0">
+                <a:solidFill>
+                  <a:srgbClr val="032254"/>
+                </a:solidFill>
+                <a:latin typeface="Aptos" pitchFamily="34" charset="0"/>
+                <a:ea typeface="Aptos" pitchFamily="34" charset="-122"/>
+                <a:cs typeface="Aptos" pitchFamily="34" charset="-120"/>
               </a:rPr>
               <a:t>Items as code</a:t>
             </a:r>
             <a:pPr indent="0" marL="0">
               <a:spcAft>
-                <a:spcPts val="500"/>
-              </a:spcAft>
-              <a:buNone/>
-            </a:pPr>
-            <a:r>
-              <a:rPr lang="en-US" sz="860" dirty="0">
-                <a:solidFill>
-                  <a:srgbClr val="404040"/>
-                </a:solidFill>
-                <a:latin typeface="Segoe UI" pitchFamily="34" charset="0"/>
-                <a:ea typeface="Segoe UI" pitchFamily="34" charset="-122"/>
-                <a:cs typeface="Segoe UI" pitchFamily="34" charset="-120"/>
+                <a:spcPts val="300"/>
+              </a:spcAft>
+              <a:buNone/>
+            </a:pPr>
+            <a:r>
+              <a:rPr lang="en-US" sz="800" dirty="0">
+                <a:solidFill>
+                  <a:srgbClr val="47494E"/>
+                </a:solidFill>
+                <a:latin typeface="Aptos" pitchFamily="34" charset="0"/>
+                <a:ea typeface="Aptos" pitchFamily="34" charset="-122"/>
+                <a:cs typeface="Aptos" pitchFamily="34" charset="-120"/>
               </a:rPr>
               <a:t> — lakehouses, notebooks, warehouses</a:t>
             </a:r>
-            <a:endParaRPr lang="en-US" sz="860" dirty="0"/>
-          </a:p>
-          <a:p>
-            <a:pPr indent="0" marL="0">
-              <a:spcAft>
-                <a:spcPts val="500"/>
-              </a:spcAft>
-              <a:buNone/>
-            </a:pPr>
-            <a:r>
-              <a:rPr lang="en-US" sz="860" b="1" dirty="0">
-                <a:solidFill>
-                  <a:srgbClr val="404040"/>
-                </a:solidFill>
-                <a:latin typeface="Segoe UI" pitchFamily="34" charset="0"/>
-                <a:ea typeface="Segoe UI" pitchFamily="34" charset="-122"/>
-                <a:cs typeface="Segoe UI" pitchFamily="34" charset="-120"/>
+            <a:endParaRPr lang="en-US" sz="800" dirty="0"/>
+          </a:p>
+          <a:p>
+            <a:pPr indent="0" marL="0">
+              <a:spcAft>
+                <a:spcPts val="300"/>
+              </a:spcAft>
+              <a:buNone/>
+            </a:pPr>
+            <a:r>
+              <a:rPr lang="en-US" sz="800" b="1" dirty="0">
+                <a:solidFill>
+                  <a:srgbClr val="032254"/>
+                </a:solidFill>
+                <a:latin typeface="Aptos" pitchFamily="34" charset="0"/>
+                <a:ea typeface="Aptos" pitchFamily="34" charset="-122"/>
+                <a:cs typeface="Aptos" pitchFamily="34" charset="-120"/>
               </a:rPr>
               <a:t>Domains, capacities, Purview</a:t>
             </a:r>
             <a:pPr indent="0" marL="0">
               <a:spcAft>
-                <a:spcPts val="500"/>
-              </a:spcAft>
-              <a:buNone/>
-            </a:pPr>
-            <a:r>
-              <a:rPr lang="en-US" sz="860" dirty="0">
-                <a:solidFill>
-                  <a:srgbClr val="404040"/>
-                </a:solidFill>
-                <a:latin typeface="Segoe UI" pitchFamily="34" charset="0"/>
-                <a:ea typeface="Segoe UI" pitchFamily="34" charset="-122"/>
-                <a:cs typeface="Segoe UI" pitchFamily="34" charset="-120"/>
+                <a:spcPts val="300"/>
+              </a:spcAft>
+              <a:buNone/>
+            </a:pPr>
+            <a:r>
+              <a:rPr lang="en-US" sz="800" dirty="0">
+                <a:solidFill>
+                  <a:srgbClr val="47494E"/>
+                </a:solidFill>
+                <a:latin typeface="Aptos" pitchFamily="34" charset="0"/>
+                <a:ea typeface="Aptos" pitchFamily="34" charset="-122"/>
+                <a:cs typeface="Aptos" pitchFamily="34" charset="-120"/>
               </a:rPr>
               <a:t> sensitivity labels</a:t>
             </a:r>
-            <a:endParaRPr lang="en-US" sz="860" dirty="0"/>
-          </a:p>
-          <a:p>
-            <a:pPr indent="0" marL="0">
-              <a:spcAft>
-                <a:spcPts val="500"/>
-              </a:spcAft>
-              <a:buNone/>
-            </a:pPr>
-            <a:r>
-              <a:rPr lang="en-US" sz="860" b="1" dirty="0">
-                <a:solidFill>
-                  <a:srgbClr val="404040"/>
-                </a:solidFill>
-                <a:latin typeface="Segoe UI" pitchFamily="34" charset="0"/>
-                <a:ea typeface="Segoe UI" pitchFamily="34" charset="-122"/>
-                <a:cs typeface="Segoe UI" pitchFamily="34" charset="-120"/>
+            <a:endParaRPr lang="en-US" sz="800" dirty="0"/>
+          </a:p>
+          <a:p>
+            <a:pPr indent="0" marL="0">
+              <a:spcAft>
+                <a:spcPts val="300"/>
+              </a:spcAft>
+              <a:buNone/>
+            </a:pPr>
+            <a:r>
+              <a:rPr lang="en-US" sz="800" b="1" dirty="0">
+                <a:solidFill>
+                  <a:srgbClr val="032254"/>
+                </a:solidFill>
+                <a:latin typeface="Aptos" pitchFamily="34" charset="0"/>
+                <a:ea typeface="Aptos" pitchFamily="34" charset="-122"/>
+                <a:cs typeface="Aptos" pitchFamily="34" charset="-120"/>
               </a:rPr>
               <a:t>Group-first RBAC</a:t>
             </a:r>
             <a:pPr indent="0" marL="0">
               <a:spcAft>
-                <a:spcPts val="500"/>
-              </a:spcAft>
-              <a:buNone/>
-            </a:pPr>
-            <a:r>
-              <a:rPr lang="en-US" sz="860" dirty="0">
-                <a:solidFill>
-                  <a:srgbClr val="404040"/>
-                </a:solidFill>
-                <a:latin typeface="Segoe UI" pitchFamily="34" charset="0"/>
-                <a:ea typeface="Segoe UI" pitchFamily="34" charset="-122"/>
-                <a:cs typeface="Segoe UI" pitchFamily="34" charset="-120"/>
-              </a:rPr>
-              <a:t>, expiring access, quarterly reviews</a:t>
-            </a:r>
-            <a:endParaRPr lang="en-US" sz="860" dirty="0"/>
-          </a:p>
-          <a:p>
-            <a:pPr indent="0" marL="0">
-              <a:spcAft>
-                <a:spcPts val="500"/>
-              </a:spcAft>
-              <a:buNone/>
-            </a:pPr>
-            <a:r>
-              <a:rPr lang="en-US" sz="600" dirty="0">
-                <a:solidFill>
-                  <a:srgbClr val="404040"/>
-                </a:solidFill>
-                <a:latin typeface="Segoe UI" pitchFamily="34" charset="0"/>
-                <a:ea typeface="Segoe UI" pitchFamily="34" charset="-122"/>
-                <a:cs typeface="Segoe UI" pitchFamily="34" charset="-120"/>
+                <a:spcPts val="300"/>
+              </a:spcAft>
+              <a:buNone/>
+            </a:pPr>
+            <a:r>
+              <a:rPr lang="en-US" sz="800" dirty="0">
+                <a:solidFill>
+                  <a:srgbClr val="47494E"/>
+                </a:solidFill>
+                <a:latin typeface="Aptos" pitchFamily="34" charset="0"/>
+                <a:ea typeface="Aptos" pitchFamily="34" charset="-122"/>
+                <a:cs typeface="Aptos" pitchFamily="34" charset="-120"/>
+              </a:rPr>
+              <a:t> + expiring access &amp; reviews</a:t>
+            </a:r>
+            <a:endParaRPr lang="en-US" sz="800" dirty="0"/>
+          </a:p>
+          <a:p>
+            <a:pPr indent="0" marL="0">
+              <a:spcAft>
+                <a:spcPts val="300"/>
+              </a:spcAft>
+              <a:buNone/>
+            </a:pPr>
+            <a:r>
+              <a:rPr lang="en-US" sz="300" dirty="0">
+                <a:solidFill>
+                  <a:srgbClr val="47494E"/>
+                </a:solidFill>
+                <a:latin typeface="Aptos" pitchFamily="34" charset="0"/>
+                <a:ea typeface="Aptos" pitchFamily="34" charset="-122"/>
+                <a:cs typeface="Aptos" pitchFamily="34" charset="-120"/>
               </a:rPr>
               <a:t> </a:t>
             </a:r>
-            <a:endParaRPr lang="en-US" sz="860" dirty="0"/>
-          </a:p>
-          <a:p>
-            <a:pPr indent="0" marL="0">
-              <a:spcAft>
-                <a:spcPts val="500"/>
+            <a:endParaRPr lang="en-US" sz="800" dirty="0"/>
+          </a:p>
+          <a:p>
+            <a:pPr indent="0" marL="0">
+              <a:spcAft>
+                <a:spcPts val="300"/>
               </a:spcAft>
               <a:buNone/>
             </a:pPr>
             <a:r>
               <a:rPr lang="en-US" sz="750" b="1" spc="100" kern="0" dirty="0">
                 <a:solidFill>
-                  <a:srgbClr val="808080"/>
-                </a:solidFill>
-                <a:latin typeface="Segoe UI" pitchFamily="34" charset="0"/>
-                <a:ea typeface="Segoe UI" pitchFamily="34" charset="-122"/>
-                <a:cs typeface="Segoe UI" pitchFamily="34" charset="-120"/>
+                  <a:srgbClr val="6B7280"/>
+                </a:solidFill>
+                <a:latin typeface="Aptos" pitchFamily="34" charset="0"/>
+                <a:ea typeface="Aptos" pitchFamily="34" charset="-122"/>
+                <a:cs typeface="Aptos" pitchFamily="34" charset="-120"/>
               </a:rPr>
               <a:t>OUTPUT</a:t>
             </a:r>
-            <a:endParaRPr lang="en-US" sz="860" dirty="0"/>
-          </a:p>
-          <a:p>
-            <a:pPr indent="0" marL="0">
-              <a:spcAft>
-                <a:spcPts val="500"/>
-              </a:spcAft>
-              <a:buNone/>
-            </a:pPr>
-            <a:r>
-              <a:rPr lang="en-US" sz="860" b="1" dirty="0">
-                <a:solidFill>
-                  <a:srgbClr val="404040"/>
-                </a:solidFill>
-                <a:latin typeface="Segoe UI" pitchFamily="34" charset="0"/>
-                <a:ea typeface="Segoe UI" pitchFamily="34" charset="-122"/>
-                <a:cs typeface="Segoe UI" pitchFamily="34" charset="-120"/>
+            <a:endParaRPr lang="en-US" sz="800" dirty="0"/>
+          </a:p>
+          <a:p>
+            <a:pPr indent="0" marL="0">
+              <a:spcAft>
+                <a:spcPts val="300"/>
+              </a:spcAft>
+              <a:buNone/>
+            </a:pPr>
+            <a:r>
+              <a:rPr lang="en-US" sz="800" b="1" dirty="0">
+                <a:solidFill>
+                  <a:srgbClr val="032254"/>
+                </a:solidFill>
+                <a:latin typeface="Aptos" pitchFamily="34" charset="0"/>
+                <a:ea typeface="Aptos" pitchFamily="34" charset="-122"/>
+                <a:cs typeface="Aptos" pitchFamily="34" charset="-120"/>
               </a:rPr>
               <a:t>Least-privilege, classified</a:t>
             </a:r>
             <a:pPr indent="0" marL="0">
               <a:spcAft>
-                <a:spcPts val="500"/>
-              </a:spcAft>
-              <a:buNone/>
-            </a:pPr>
-            <a:r>
-              <a:rPr lang="en-US" sz="860" dirty="0">
-                <a:solidFill>
-                  <a:srgbClr val="404040"/>
-                </a:solidFill>
-                <a:latin typeface="Segoe UI" pitchFamily="34" charset="0"/>
-                <a:ea typeface="Segoe UI" pitchFamily="34" charset="-122"/>
-                <a:cs typeface="Segoe UI" pitchFamily="34" charset="-120"/>
-              </a:rPr>
-              <a:t> estate with accurate chargeback</a:t>
-            </a:r>
-            <a:endParaRPr lang="en-US" sz="860" dirty="0"/>
-          </a:p>
-          <a:p>
-            <a:pPr indent="0" marL="0">
-              <a:spcAft>
-                <a:spcPts val="500"/>
+                <a:spcPts val="300"/>
+              </a:spcAft>
+              <a:buNone/>
+            </a:pPr>
+            <a:r>
+              <a:rPr lang="en-US" sz="800" dirty="0">
+                <a:solidFill>
+                  <a:srgbClr val="47494E"/>
+                </a:solidFill>
+                <a:latin typeface="Aptos" pitchFamily="34" charset="0"/>
+                <a:ea typeface="Aptos" pitchFamily="34" charset="-122"/>
+                <a:cs typeface="Aptos" pitchFamily="34" charset="-120"/>
+              </a:rPr>
+              <a:t> estate + accurate chargeback</a:t>
+            </a:r>
+            <a:endParaRPr lang="en-US" sz="800" dirty="0"/>
+          </a:p>
+          <a:p>
+            <a:pPr indent="0" marL="0">
+              <a:spcAft>
+                <a:spcPts val="300"/>
               </a:spcAft>
               <a:buNone/>
             </a:pPr>
             <a:r>
               <a:rPr lang="en-US" sz="750" i="1" dirty="0">
                 <a:solidFill>
-                  <a:srgbClr val="A6A6A6"/>
-                </a:solidFill>
-                <a:latin typeface="Segoe UI" pitchFamily="34" charset="0"/>
-                <a:ea typeface="Segoe UI" pitchFamily="34" charset="-122"/>
-                <a:cs typeface="Segoe UI" pitchFamily="34" charset="-120"/>
+                  <a:srgbClr val="6B7280"/>
+                </a:solidFill>
+                <a:latin typeface="Aptos" pitchFamily="34" charset="0"/>
+                <a:ea typeface="Aptos" pitchFamily="34" charset="-122"/>
+                <a:cs typeface="Aptos" pitchFamily="34" charset="-120"/>
               </a:rPr>
               <a:t>Challenges 02–04</a:t>
             </a:r>
-            <a:endParaRPr lang="en-US" sz="860" dirty="0"/>
+            <a:endParaRPr lang="en-US" sz="800" dirty="0"/>
           </a:p>
         </p:txBody>
       </p:sp>
       <p:sp>
         <p:nvSpPr>
-          <p:cNvPr id="38" name="Text 36"/>
-          <p:cNvSpPr/>
-          <p:nvPr/>
-        </p:nvSpPr>
-        <p:spPr>
-          <a:xfrm>
-            <a:off x="7349947" y="4297680"/>
-            <a:ext cx="2072030" cy="1975104"/>
+          <p:cNvPr id="53" name="Text 50"/>
+          <p:cNvSpPr/>
+          <p:nvPr/>
+        </p:nvSpPr>
+        <p:spPr>
+          <a:xfrm>
+            <a:off x="7349947" y="4361688"/>
+            <a:ext cx="2072030" cy="1783080"/>
           </a:xfrm>
           <a:prstGeom prst="rect">
             <a:avLst/>
@@ -3178,260 +3598,260 @@
           <a:p>
             <a:pPr indent="0" marL="0">
               <a:spcAft>
-                <a:spcPts val="500"/>
-              </a:spcAft>
-              <a:buNone/>
-            </a:pPr>
-            <a:r>
-              <a:rPr lang="en-US" sz="860" b="1" dirty="0">
-                <a:solidFill>
-                  <a:srgbClr val="404040"/>
-                </a:solidFill>
-                <a:latin typeface="Segoe UI" pitchFamily="34" charset="0"/>
-                <a:ea typeface="Segoe UI" pitchFamily="34" charset="-122"/>
-                <a:cs typeface="Segoe UI" pitchFamily="34" charset="-120"/>
+                <a:spcPts val="300"/>
+              </a:spcAft>
+              <a:buNone/>
+            </a:pPr>
+            <a:r>
+              <a:rPr lang="en-US" sz="800" b="1" dirty="0">
+                <a:solidFill>
+                  <a:srgbClr val="032254"/>
+                </a:solidFill>
+                <a:latin typeface="Aptos" pitchFamily="34" charset="0"/>
+                <a:ea typeface="Aptos" pitchFamily="34" charset="-122"/>
+                <a:cs typeface="Aptos" pitchFamily="34" charset="-120"/>
               </a:rPr>
               <a:t>Medallion</a:t>
             </a:r>
             <a:pPr indent="0" marL="0">
               <a:spcAft>
-                <a:spcPts val="500"/>
-              </a:spcAft>
-              <a:buNone/>
-            </a:pPr>
-            <a:r>
-              <a:rPr lang="en-US" sz="860" dirty="0">
-                <a:solidFill>
-                  <a:srgbClr val="404040"/>
-                </a:solidFill>
-                <a:latin typeface="Segoe UI" pitchFamily="34" charset="0"/>
-                <a:ea typeface="Segoe UI" pitchFamily="34" charset="-122"/>
-                <a:cs typeface="Segoe UI" pitchFamily="34" charset="-120"/>
+                <a:spcPts val="300"/>
+              </a:spcAft>
+              <a:buNone/>
+            </a:pPr>
+            <a:r>
+              <a:rPr lang="en-US" sz="800" dirty="0">
+                <a:solidFill>
+                  <a:srgbClr val="47494E"/>
+                </a:solidFill>
+                <a:latin typeface="Aptos" pitchFamily="34" charset="0"/>
+                <a:ea typeface="Aptos" pitchFamily="34" charset="-122"/>
+                <a:cs typeface="Aptos" pitchFamily="34" charset="-120"/>
               </a:rPr>
               <a:t> Bronze/Silver/Gold in one PR</a:t>
             </a:r>
-            <a:endParaRPr lang="en-US" sz="860" dirty="0"/>
-          </a:p>
-          <a:p>
-            <a:pPr indent="0" marL="0">
-              <a:spcAft>
-                <a:spcPts val="500"/>
-              </a:spcAft>
-              <a:buNone/>
-            </a:pPr>
-            <a:r>
-              <a:rPr lang="en-US" sz="860" b="1" dirty="0">
-                <a:solidFill>
-                  <a:srgbClr val="404040"/>
-                </a:solidFill>
-                <a:latin typeface="Segoe UI" pitchFamily="34" charset="0"/>
-                <a:ea typeface="Segoe UI" pitchFamily="34" charset="-122"/>
-                <a:cs typeface="Segoe UI" pitchFamily="34" charset="-120"/>
+            <a:endParaRPr lang="en-US" sz="800" dirty="0"/>
+          </a:p>
+          <a:p>
+            <a:pPr indent="0" marL="0">
+              <a:spcAft>
+                <a:spcPts val="300"/>
+              </a:spcAft>
+              <a:buNone/>
+            </a:pPr>
+            <a:r>
+              <a:rPr lang="en-US" sz="800" b="1" dirty="0">
+                <a:solidFill>
+                  <a:srgbClr val="032254"/>
+                </a:solidFill>
+                <a:latin typeface="Aptos" pitchFamily="34" charset="0"/>
+                <a:ea typeface="Aptos" pitchFamily="34" charset="-122"/>
+                <a:cs typeface="Aptos" pitchFamily="34" charset="-120"/>
               </a:rPr>
               <a:t>Governed Data Agents</a:t>
             </a:r>
             <a:pPr indent="0" marL="0">
               <a:spcAft>
-                <a:spcPts val="500"/>
-              </a:spcAft>
-              <a:buNone/>
-            </a:pPr>
-            <a:r>
-              <a:rPr lang="en-US" sz="860" dirty="0">
-                <a:solidFill>
-                  <a:srgbClr val="404040"/>
-                </a:solidFill>
-                <a:latin typeface="Segoe UI" pitchFamily="34" charset="0"/>
-                <a:ea typeface="Segoe UI" pitchFamily="34" charset="-122"/>
-                <a:cs typeface="Segoe UI" pitchFamily="34" charset="-120"/>
-              </a:rPr>
-              <a:t> over allow-listed sources</a:t>
-            </a:r>
-            <a:endParaRPr lang="en-US" sz="860" dirty="0"/>
-          </a:p>
-          <a:p>
-            <a:pPr indent="0" marL="0">
-              <a:spcAft>
-                <a:spcPts val="500"/>
-              </a:spcAft>
-              <a:buNone/>
-            </a:pPr>
-            <a:r>
-              <a:rPr lang="en-US" sz="860" dirty="0">
-                <a:solidFill>
-                  <a:srgbClr val="404040"/>
-                </a:solidFill>
-                <a:latin typeface="Segoe UI" pitchFamily="34" charset="0"/>
-                <a:ea typeface="Segoe UI" pitchFamily="34" charset="-122"/>
-                <a:cs typeface="Segoe UI" pitchFamily="34" charset="-120"/>
+                <a:spcPts val="300"/>
+              </a:spcAft>
+              <a:buNone/>
+            </a:pPr>
+            <a:r>
+              <a:rPr lang="en-US" sz="800" dirty="0">
+                <a:solidFill>
+                  <a:srgbClr val="47494E"/>
+                </a:solidFill>
+                <a:latin typeface="Aptos" pitchFamily="34" charset="0"/>
+                <a:ea typeface="Aptos" pitchFamily="34" charset="-122"/>
+                <a:cs typeface="Aptos" pitchFamily="34" charset="-120"/>
+              </a:rPr>
+              <a:t> on allow-listed sources</a:t>
+            </a:r>
+            <a:endParaRPr lang="en-US" sz="800" dirty="0"/>
+          </a:p>
+          <a:p>
+            <a:pPr indent="0" marL="0">
+              <a:spcAft>
+                <a:spcPts val="300"/>
+              </a:spcAft>
+              <a:buNone/>
+            </a:pPr>
+            <a:r>
+              <a:rPr lang="en-US" sz="800" dirty="0">
+                <a:solidFill>
+                  <a:srgbClr val="47494E"/>
+                </a:solidFill>
+                <a:latin typeface="Aptos" pitchFamily="34" charset="0"/>
+                <a:ea typeface="Aptos" pitchFamily="34" charset="-122"/>
+                <a:cs typeface="Aptos" pitchFamily="34" charset="-120"/>
               </a:rPr>
               <a:t>Real-time </a:t>
             </a:r>
             <a:pPr indent="0" marL="0">
               <a:spcAft>
-                <a:spcPts val="500"/>
-              </a:spcAft>
-              <a:buNone/>
-            </a:pPr>
-            <a:r>
-              <a:rPr lang="en-US" sz="860" b="1" dirty="0">
-                <a:solidFill>
-                  <a:srgbClr val="404040"/>
-                </a:solidFill>
-                <a:latin typeface="Segoe UI" pitchFamily="34" charset="0"/>
-                <a:ea typeface="Segoe UI" pitchFamily="34" charset="-122"/>
-                <a:cs typeface="Segoe UI" pitchFamily="34" charset="-120"/>
-              </a:rPr>
-              <a:t>audit Eventhouse + dashboard + alerts</a:t>
-            </a:r>
-            <a:endParaRPr lang="en-US" sz="860" dirty="0"/>
-          </a:p>
-          <a:p>
-            <a:pPr indent="0" marL="0">
-              <a:spcAft>
-                <a:spcPts val="500"/>
-              </a:spcAft>
-              <a:buNone/>
-            </a:pPr>
-            <a:r>
-              <a:rPr lang="en-US" sz="860" b="1" dirty="0">
-                <a:solidFill>
-                  <a:srgbClr val="404040"/>
-                </a:solidFill>
-                <a:latin typeface="Segoe UI" pitchFamily="34" charset="0"/>
-                <a:ea typeface="Segoe UI" pitchFamily="34" charset="-122"/>
-                <a:cs typeface="Segoe UI" pitchFamily="34" charset="-120"/>
+                <a:spcPts val="300"/>
+              </a:spcAft>
+              <a:buNone/>
+            </a:pPr>
+            <a:r>
+              <a:rPr lang="en-US" sz="800" b="1" dirty="0">
+                <a:solidFill>
+                  <a:srgbClr val="032254"/>
+                </a:solidFill>
+                <a:latin typeface="Aptos" pitchFamily="34" charset="0"/>
+                <a:ea typeface="Aptos" pitchFamily="34" charset="-122"/>
+                <a:cs typeface="Aptos" pitchFamily="34" charset="-120"/>
+              </a:rPr>
+              <a:t>audit Eventhouse + dashboards</a:t>
+            </a:r>
+            <a:endParaRPr lang="en-US" sz="800" dirty="0"/>
+          </a:p>
+          <a:p>
+            <a:pPr indent="0" marL="0">
+              <a:spcAft>
+                <a:spcPts val="300"/>
+              </a:spcAft>
+              <a:buNone/>
+            </a:pPr>
+            <a:r>
+              <a:rPr lang="en-US" sz="800" b="1" dirty="0">
+                <a:solidFill>
+                  <a:srgbClr val="032254"/>
+                </a:solidFill>
+                <a:latin typeface="Aptos" pitchFamily="34" charset="0"/>
+                <a:ea typeface="Aptos" pitchFamily="34" charset="-122"/>
+                <a:cs typeface="Aptos" pitchFamily="34" charset="-120"/>
               </a:rPr>
               <a:t>dev → stg → prd</a:t>
             </a:r>
             <a:pPr indent="0" marL="0">
               <a:spcAft>
-                <a:spcPts val="500"/>
-              </a:spcAft>
-              <a:buNone/>
-            </a:pPr>
-            <a:r>
-              <a:rPr lang="en-US" sz="860" dirty="0">
-                <a:solidFill>
-                  <a:srgbClr val="404040"/>
-                </a:solidFill>
-                <a:latin typeface="Segoe UI" pitchFamily="34" charset="0"/>
-                <a:ea typeface="Segoe UI" pitchFamily="34" charset="-122"/>
-                <a:cs typeface="Segoe UI" pitchFamily="34" charset="-120"/>
-              </a:rPr>
-              <a:t> promotion with rollback</a:t>
-            </a:r>
-            <a:endParaRPr lang="en-US" sz="860" dirty="0"/>
-          </a:p>
-          <a:p>
-            <a:pPr indent="0" marL="0">
-              <a:spcAft>
-                <a:spcPts val="500"/>
-              </a:spcAft>
-              <a:buNone/>
-            </a:pPr>
-            <a:r>
-              <a:rPr lang="en-US" sz="600" dirty="0">
-                <a:solidFill>
-                  <a:srgbClr val="404040"/>
-                </a:solidFill>
-                <a:latin typeface="Segoe UI" pitchFamily="34" charset="0"/>
-                <a:ea typeface="Segoe UI" pitchFamily="34" charset="-122"/>
-                <a:cs typeface="Segoe UI" pitchFamily="34" charset="-120"/>
+                <a:spcPts val="300"/>
+              </a:spcAft>
+              <a:buNone/>
+            </a:pPr>
+            <a:r>
+              <a:rPr lang="en-US" sz="800" dirty="0">
+                <a:solidFill>
+                  <a:srgbClr val="47494E"/>
+                </a:solidFill>
+                <a:latin typeface="Aptos" pitchFamily="34" charset="0"/>
+                <a:ea typeface="Aptos" pitchFamily="34" charset="-122"/>
+                <a:cs typeface="Aptos" pitchFamily="34" charset="-120"/>
+              </a:rPr>
+              <a:t> promotion + rollback</a:t>
+            </a:r>
+            <a:endParaRPr lang="en-US" sz="800" dirty="0"/>
+          </a:p>
+          <a:p>
+            <a:pPr indent="0" marL="0">
+              <a:spcAft>
+                <a:spcPts val="300"/>
+              </a:spcAft>
+              <a:buNone/>
+            </a:pPr>
+            <a:r>
+              <a:rPr lang="en-US" sz="300" dirty="0">
+                <a:solidFill>
+                  <a:srgbClr val="47494E"/>
+                </a:solidFill>
+                <a:latin typeface="Aptos" pitchFamily="34" charset="0"/>
+                <a:ea typeface="Aptos" pitchFamily="34" charset="-122"/>
+                <a:cs typeface="Aptos" pitchFamily="34" charset="-120"/>
               </a:rPr>
               <a:t> </a:t>
             </a:r>
-            <a:endParaRPr lang="en-US" sz="860" dirty="0"/>
-          </a:p>
-          <a:p>
-            <a:pPr indent="0" marL="0">
-              <a:spcAft>
-                <a:spcPts val="500"/>
+            <a:endParaRPr lang="en-US" sz="800" dirty="0"/>
+          </a:p>
+          <a:p>
+            <a:pPr indent="0" marL="0">
+              <a:spcAft>
+                <a:spcPts val="300"/>
               </a:spcAft>
               <a:buNone/>
             </a:pPr>
             <a:r>
               <a:rPr lang="en-US" sz="750" b="1" spc="100" kern="0" dirty="0">
                 <a:solidFill>
-                  <a:srgbClr val="808080"/>
-                </a:solidFill>
-                <a:latin typeface="Segoe UI" pitchFamily="34" charset="0"/>
-                <a:ea typeface="Segoe UI" pitchFamily="34" charset="-122"/>
-                <a:cs typeface="Segoe UI" pitchFamily="34" charset="-120"/>
+                  <a:srgbClr val="6B7280"/>
+                </a:solidFill>
+                <a:latin typeface="Aptos" pitchFamily="34" charset="0"/>
+                <a:ea typeface="Aptos" pitchFamily="34" charset="-122"/>
+                <a:cs typeface="Aptos" pitchFamily="34" charset="-120"/>
               </a:rPr>
               <a:t>OUTPUT</a:t>
             </a:r>
-            <a:endParaRPr lang="en-US" sz="860" dirty="0"/>
-          </a:p>
-          <a:p>
-            <a:pPr indent="0" marL="0">
-              <a:spcAft>
-                <a:spcPts val="500"/>
-              </a:spcAft>
-              <a:buNone/>
-            </a:pPr>
-            <a:r>
-              <a:rPr lang="en-US" sz="860" b="1" dirty="0">
-                <a:solidFill>
-                  <a:srgbClr val="404040"/>
-                </a:solidFill>
-                <a:latin typeface="Segoe UI" pitchFamily="34" charset="0"/>
-                <a:ea typeface="Segoe UI" pitchFamily="34" charset="-122"/>
-                <a:cs typeface="Segoe UI" pitchFamily="34" charset="-120"/>
+            <a:endParaRPr lang="en-US" sz="800" dirty="0"/>
+          </a:p>
+          <a:p>
+            <a:pPr indent="0" marL="0">
+              <a:spcAft>
+                <a:spcPts val="300"/>
+              </a:spcAft>
+              <a:buNone/>
+            </a:pPr>
+            <a:r>
+              <a:rPr lang="en-US" sz="800" b="1" dirty="0">
+                <a:solidFill>
+                  <a:srgbClr val="032254"/>
+                </a:solidFill>
+                <a:latin typeface="Aptos" pitchFamily="34" charset="0"/>
+                <a:ea typeface="Aptos" pitchFamily="34" charset="-122"/>
+                <a:cs typeface="Aptos" pitchFamily="34" charset="-120"/>
               </a:rPr>
               <a:t>Governance you can see</a:t>
             </a:r>
             <a:pPr indent="0" marL="0">
               <a:spcAft>
-                <a:spcPts val="500"/>
-              </a:spcAft>
-              <a:buNone/>
-            </a:pPr>
-            <a:r>
-              <a:rPr lang="en-US" sz="860" dirty="0">
-                <a:solidFill>
-                  <a:srgbClr val="404040"/>
-                </a:solidFill>
-                <a:latin typeface="Segoe UI" pitchFamily="34" charset="0"/>
-                <a:ea typeface="Segoe UI" pitchFamily="34" charset="-122"/>
-                <a:cs typeface="Segoe UI" pitchFamily="34" charset="-120"/>
-              </a:rPr>
-              <a:t>; repeatable, reversible releases</a:t>
-            </a:r>
-            <a:endParaRPr lang="en-US" sz="860" dirty="0"/>
-          </a:p>
-          <a:p>
-            <a:pPr indent="0" marL="0">
-              <a:spcAft>
-                <a:spcPts val="500"/>
+                <a:spcPts val="300"/>
+              </a:spcAft>
+              <a:buNone/>
+            </a:pPr>
+            <a:r>
+              <a:rPr lang="en-US" sz="800" dirty="0">
+                <a:solidFill>
+                  <a:srgbClr val="47494E"/>
+                </a:solidFill>
+                <a:latin typeface="Aptos" pitchFamily="34" charset="0"/>
+                <a:ea typeface="Aptos" pitchFamily="34" charset="-122"/>
+                <a:cs typeface="Aptos" pitchFamily="34" charset="-120"/>
+              </a:rPr>
+              <a:t>; reversible releases</a:t>
+            </a:r>
+            <a:endParaRPr lang="en-US" sz="800" dirty="0"/>
+          </a:p>
+          <a:p>
+            <a:pPr indent="0" marL="0">
+              <a:spcAft>
+                <a:spcPts val="300"/>
               </a:spcAft>
               <a:buNone/>
             </a:pPr>
             <a:r>
               <a:rPr lang="en-US" sz="750" i="1" dirty="0">
                 <a:solidFill>
-                  <a:srgbClr val="A6A6A6"/>
-                </a:solidFill>
-                <a:latin typeface="Segoe UI" pitchFamily="34" charset="0"/>
-                <a:ea typeface="Segoe UI" pitchFamily="34" charset="-122"/>
-                <a:cs typeface="Segoe UI" pitchFamily="34" charset="-120"/>
+                  <a:srgbClr val="6B7280"/>
+                </a:solidFill>
+                <a:latin typeface="Aptos" pitchFamily="34" charset="0"/>
+                <a:ea typeface="Aptos" pitchFamily="34" charset="-122"/>
+                <a:cs typeface="Aptos" pitchFamily="34" charset="-120"/>
               </a:rPr>
               <a:t>Challenges 05–08</a:t>
             </a:r>
-            <a:endParaRPr lang="en-US" sz="860" dirty="0"/>
+            <a:endParaRPr lang="en-US" sz="800" dirty="0"/>
           </a:p>
         </p:txBody>
       </p:sp>
       <p:sp>
         <p:nvSpPr>
-          <p:cNvPr id="39" name="Text 37"/>
-          <p:cNvSpPr/>
-          <p:nvPr/>
-        </p:nvSpPr>
-        <p:spPr>
-          <a:xfrm>
-            <a:off x="9641434" y="4297680"/>
-            <a:ext cx="2072030" cy="1975104"/>
+          <p:cNvPr id="54" name="Text 51"/>
+          <p:cNvSpPr/>
+          <p:nvPr/>
+        </p:nvSpPr>
+        <p:spPr>
+          <a:xfrm>
+            <a:off x="9641434" y="4361688"/>
+            <a:ext cx="2072030" cy="1783080"/>
           </a:xfrm>
           <a:prstGeom prst="rect">
             <a:avLst/>
@@ -3445,257 +3865,257 @@
           <a:p>
             <a:pPr indent="0" marL="0">
               <a:spcAft>
-                <a:spcPts val="500"/>
-              </a:spcAft>
-              <a:buNone/>
-            </a:pPr>
-            <a:r>
-              <a:rPr lang="en-US" sz="860" dirty="0">
-                <a:solidFill>
-                  <a:srgbClr val="404040"/>
-                </a:solidFill>
-                <a:latin typeface="Segoe UI" pitchFamily="34" charset="0"/>
-                <a:ea typeface="Segoe UI" pitchFamily="34" charset="-122"/>
-                <a:cs typeface="Segoe UI" pitchFamily="34" charset="-120"/>
+                <a:spcPts val="300"/>
+              </a:spcAft>
+              <a:buNone/>
+            </a:pPr>
+            <a:r>
+              <a:rPr lang="en-US" sz="800" dirty="0">
+                <a:solidFill>
+                  <a:srgbClr val="47494E"/>
+                </a:solidFill>
+                <a:latin typeface="Aptos" pitchFamily="34" charset="0"/>
+                <a:ea typeface="Aptos" pitchFamily="34" charset="-122"/>
+                <a:cs typeface="Aptos" pitchFamily="34" charset="-120"/>
               </a:rPr>
               <a:t>One PR exercises </a:t>
             </a:r>
             <a:pPr indent="0" marL="0">
               <a:spcAft>
-                <a:spcPts val="500"/>
-              </a:spcAft>
-              <a:buNone/>
-            </a:pPr>
-            <a:r>
-              <a:rPr lang="en-US" sz="860" b="1" dirty="0">
-                <a:solidFill>
-                  <a:srgbClr val="404040"/>
-                </a:solidFill>
-                <a:latin typeface="Segoe UI" pitchFamily="34" charset="0"/>
-                <a:ea typeface="Segoe UI" pitchFamily="34" charset="-122"/>
-                <a:cs typeface="Segoe UI" pitchFamily="34" charset="-120"/>
+                <a:spcPts val="300"/>
+              </a:spcAft>
+              <a:buNone/>
+            </a:pPr>
+            <a:r>
+              <a:rPr lang="en-US" sz="800" b="1" dirty="0">
+                <a:solidFill>
+                  <a:srgbClr val="032254"/>
+                </a:solidFill>
+                <a:latin typeface="Aptos" pitchFamily="34" charset="0"/>
+                <a:ea typeface="Aptos" pitchFamily="34" charset="-122"/>
+                <a:cs typeface="Aptos" pitchFamily="34" charset="-120"/>
               </a:rPr>
               <a:t>every challenge</a:t>
             </a:r>
             <a:pPr indent="0" marL="0">
               <a:spcAft>
-                <a:spcPts val="500"/>
-              </a:spcAft>
-              <a:buNone/>
-            </a:pPr>
-            <a:r>
-              <a:rPr lang="en-US" sz="860" dirty="0">
-                <a:solidFill>
-                  <a:srgbClr val="404040"/>
-                </a:solidFill>
-                <a:latin typeface="Segoe UI" pitchFamily="34" charset="0"/>
-                <a:ea typeface="Segoe UI" pitchFamily="34" charset="-122"/>
-                <a:cs typeface="Segoe UI" pitchFamily="34" charset="-120"/>
+                <a:spcPts val="300"/>
+              </a:spcAft>
+              <a:buNone/>
+            </a:pPr>
+            <a:r>
+              <a:rPr lang="en-US" sz="800" dirty="0">
+                <a:solidFill>
+                  <a:srgbClr val="47494E"/>
+                </a:solidFill>
+                <a:latin typeface="Aptos" pitchFamily="34" charset="0"/>
+                <a:ea typeface="Aptos" pitchFamily="34" charset="-122"/>
+                <a:cs typeface="Aptos" pitchFamily="34" charset="-120"/>
               </a:rPr>
               <a:t> the team completed</a:t>
             </a:r>
-            <a:endParaRPr lang="en-US" sz="860" dirty="0"/>
-          </a:p>
-          <a:p>
-            <a:pPr indent="0" marL="0">
-              <a:spcAft>
-                <a:spcPts val="500"/>
-              </a:spcAft>
-              <a:buNone/>
-            </a:pPr>
-            <a:r>
-              <a:rPr lang="en-US" sz="860" dirty="0">
-                <a:solidFill>
-                  <a:srgbClr val="404040"/>
-                </a:solidFill>
-                <a:latin typeface="Segoe UI" pitchFamily="34" charset="0"/>
-                <a:ea typeface="Segoe UI" pitchFamily="34" charset="-122"/>
-                <a:cs typeface="Segoe UI" pitchFamily="34" charset="-120"/>
+            <a:endParaRPr lang="en-US" sz="800" dirty="0"/>
+          </a:p>
+          <a:p>
+            <a:pPr indent="0" marL="0">
+              <a:spcAft>
+                <a:spcPts val="300"/>
+              </a:spcAft>
+              <a:buNone/>
+            </a:pPr>
+            <a:r>
+              <a:rPr lang="en-US" sz="800" dirty="0">
+                <a:solidFill>
+                  <a:srgbClr val="47494E"/>
+                </a:solidFill>
+                <a:latin typeface="Aptos" pitchFamily="34" charset="0"/>
+                <a:ea typeface="Aptos" pitchFamily="34" charset="-122"/>
+                <a:cs typeface="Aptos" pitchFamily="34" charset="-120"/>
               </a:rPr>
               <a:t>Demo artifacts vs. rubric </a:t>
             </a:r>
             <a:pPr indent="0" marL="0">
               <a:spcAft>
-                <a:spcPts val="500"/>
-              </a:spcAft>
-              <a:buNone/>
-            </a:pPr>
-            <a:r>
-              <a:rPr lang="en-US" sz="860" b="1" dirty="0">
-                <a:solidFill>
-                  <a:srgbClr val="404040"/>
-                </a:solidFill>
-                <a:latin typeface="Segoe UI" pitchFamily="34" charset="0"/>
-                <a:ea typeface="Segoe UI" pitchFamily="34" charset="-122"/>
-                <a:cs typeface="Segoe UI" pitchFamily="34" charset="-120"/>
+                <a:spcPts val="300"/>
+              </a:spcAft>
+              <a:buNone/>
+            </a:pPr>
+            <a:r>
+              <a:rPr lang="en-US" sz="800" b="1" dirty="0">
+                <a:solidFill>
+                  <a:srgbClr val="032254"/>
+                </a:solidFill>
+                <a:latin typeface="Aptos" pitchFamily="34" charset="0"/>
+                <a:ea typeface="Aptos" pitchFamily="34" charset="-122"/>
+                <a:cs typeface="Aptos" pitchFamily="34" charset="-120"/>
               </a:rPr>
               <a:t>on the customer’s own data</a:t>
             </a:r>
-            <a:endParaRPr lang="en-US" sz="860" dirty="0"/>
-          </a:p>
-          <a:p>
-            <a:pPr indent="0" marL="0">
-              <a:spcAft>
-                <a:spcPts val="500"/>
-              </a:spcAft>
-              <a:buNone/>
-            </a:pPr>
-            <a:r>
-              <a:rPr lang="en-US" sz="860" dirty="0">
-                <a:solidFill>
-                  <a:srgbClr val="404040"/>
-                </a:solidFill>
-                <a:latin typeface="Segoe UI" pitchFamily="34" charset="0"/>
-                <a:ea typeface="Segoe UI" pitchFamily="34" charset="-122"/>
-                <a:cs typeface="Segoe UI" pitchFamily="34" charset="-120"/>
+            <a:endParaRPr lang="en-US" sz="800" dirty="0"/>
+          </a:p>
+          <a:p>
+            <a:pPr indent="0" marL="0">
+              <a:spcAft>
+                <a:spcPts val="300"/>
+              </a:spcAft>
+              <a:buNone/>
+            </a:pPr>
+            <a:r>
+              <a:rPr lang="en-US" sz="800" dirty="0">
+                <a:solidFill>
+                  <a:srgbClr val="47494E"/>
+                </a:solidFill>
+                <a:latin typeface="Aptos" pitchFamily="34" charset="0"/>
+                <a:ea typeface="Aptos" pitchFamily="34" charset="-122"/>
+                <a:cs typeface="Aptos" pitchFamily="34" charset="-120"/>
               </a:rPr>
               <a:t>Feedback → new / adapted challenges via </a:t>
             </a:r>
             <a:pPr indent="0" marL="0">
               <a:spcAft>
-                <a:spcPts val="500"/>
-              </a:spcAft>
-              <a:buNone/>
-            </a:pPr>
-            <a:r>
-              <a:rPr lang="en-US" sz="860" b="1" dirty="0">
-                <a:solidFill>
-                  <a:srgbClr val="404040"/>
-                </a:solidFill>
-                <a:latin typeface="Segoe UI" pitchFamily="34" charset="0"/>
-                <a:ea typeface="Segoe UI" pitchFamily="34" charset="-122"/>
-                <a:cs typeface="Segoe UI" pitchFamily="34" charset="-120"/>
+                <a:spcPts val="300"/>
+              </a:spcAft>
+              <a:buNone/>
+            </a:pPr>
+            <a:r>
+              <a:rPr lang="en-US" sz="800" b="1" dirty="0">
+                <a:solidFill>
+                  <a:srgbClr val="032254"/>
+                </a:solidFill>
+                <a:latin typeface="Aptos" pitchFamily="34" charset="0"/>
+                <a:ea typeface="Aptos" pitchFamily="34" charset="-122"/>
+                <a:cs typeface="Aptos" pitchFamily="34" charset="-120"/>
               </a:rPr>
               <a:t>fix / enhance / adapt / feat</a:t>
             </a:r>
             <a:pPr indent="0" marL="0">
               <a:spcAft>
-                <a:spcPts val="500"/>
-              </a:spcAft>
-              <a:buNone/>
-            </a:pPr>
-            <a:r>
-              <a:rPr lang="en-US" sz="860" dirty="0">
-                <a:solidFill>
-                  <a:srgbClr val="404040"/>
-                </a:solidFill>
-                <a:latin typeface="Segoe UI" pitchFamily="34" charset="0"/>
-                <a:ea typeface="Segoe UI" pitchFamily="34" charset="-122"/>
-                <a:cs typeface="Segoe UI" pitchFamily="34" charset="-120"/>
+                <a:spcPts val="300"/>
+              </a:spcAft>
+              <a:buNone/>
+            </a:pPr>
+            <a:r>
+              <a:rPr lang="en-US" sz="800" dirty="0">
+                <a:solidFill>
+                  <a:srgbClr val="47494E"/>
+                </a:solidFill>
+                <a:latin typeface="Aptos" pitchFamily="34" charset="0"/>
+                <a:ea typeface="Aptos" pitchFamily="34" charset="-122"/>
+                <a:cs typeface="Aptos" pitchFamily="34" charset="-120"/>
               </a:rPr>
               <a:t> PRs</a:t>
             </a:r>
-            <a:endParaRPr lang="en-US" sz="860" dirty="0"/>
-          </a:p>
-          <a:p>
-            <a:pPr indent="0" marL="0">
-              <a:spcAft>
-                <a:spcPts val="500"/>
-              </a:spcAft>
-              <a:buNone/>
-            </a:pPr>
-            <a:r>
-              <a:rPr lang="en-US" sz="600" dirty="0">
-                <a:solidFill>
-                  <a:srgbClr val="404040"/>
-                </a:solidFill>
-                <a:latin typeface="Segoe UI" pitchFamily="34" charset="0"/>
-                <a:ea typeface="Segoe UI" pitchFamily="34" charset="-122"/>
-                <a:cs typeface="Segoe UI" pitchFamily="34" charset="-120"/>
+            <a:endParaRPr lang="en-US" sz="800" dirty="0"/>
+          </a:p>
+          <a:p>
+            <a:pPr indent="0" marL="0">
+              <a:spcAft>
+                <a:spcPts val="300"/>
+              </a:spcAft>
+              <a:buNone/>
+            </a:pPr>
+            <a:r>
+              <a:rPr lang="en-US" sz="300" dirty="0">
+                <a:solidFill>
+                  <a:srgbClr val="47494E"/>
+                </a:solidFill>
+                <a:latin typeface="Aptos" pitchFamily="34" charset="0"/>
+                <a:ea typeface="Aptos" pitchFamily="34" charset="-122"/>
+                <a:cs typeface="Aptos" pitchFamily="34" charset="-120"/>
               </a:rPr>
               <a:t> </a:t>
             </a:r>
-            <a:endParaRPr lang="en-US" sz="860" dirty="0"/>
-          </a:p>
-          <a:p>
-            <a:pPr indent="0" marL="0">
-              <a:spcAft>
-                <a:spcPts val="500"/>
+            <a:endParaRPr lang="en-US" sz="800" dirty="0"/>
+          </a:p>
+          <a:p>
+            <a:pPr indent="0" marL="0">
+              <a:spcAft>
+                <a:spcPts val="300"/>
               </a:spcAft>
               <a:buNone/>
             </a:pPr>
             <a:r>
               <a:rPr lang="en-US" sz="750" b="1" spc="100" kern="0" dirty="0">
                 <a:solidFill>
-                  <a:srgbClr val="808080"/>
-                </a:solidFill>
-                <a:latin typeface="Segoe UI" pitchFamily="34" charset="0"/>
-                <a:ea typeface="Segoe UI" pitchFamily="34" charset="-122"/>
-                <a:cs typeface="Segoe UI" pitchFamily="34" charset="-120"/>
+                  <a:srgbClr val="6B7280"/>
+                </a:solidFill>
+                <a:latin typeface="Aptos" pitchFamily="34" charset="0"/>
+                <a:ea typeface="Aptos" pitchFamily="34" charset="-122"/>
+                <a:cs typeface="Aptos" pitchFamily="34" charset="-120"/>
               </a:rPr>
               <a:t>OUTPUT</a:t>
             </a:r>
-            <a:endParaRPr lang="en-US" sz="860" dirty="0"/>
-          </a:p>
-          <a:p>
-            <a:pPr indent="0" marL="0">
-              <a:spcAft>
-                <a:spcPts val="500"/>
-              </a:spcAft>
-              <a:buNone/>
-            </a:pPr>
-            <a:r>
-              <a:rPr lang="en-US" sz="860" b="1" dirty="0">
-                <a:solidFill>
-                  <a:srgbClr val="404040"/>
-                </a:solidFill>
-                <a:latin typeface="Segoe UI" pitchFamily="34" charset="0"/>
-                <a:ea typeface="Segoe UI" pitchFamily="34" charset="-122"/>
-                <a:cs typeface="Segoe UI" pitchFamily="34" charset="-120"/>
+            <a:endParaRPr lang="en-US" sz="800" dirty="0"/>
+          </a:p>
+          <a:p>
+            <a:pPr indent="0" marL="0">
+              <a:spcAft>
+                <a:spcPts val="300"/>
+              </a:spcAft>
+              <a:buNone/>
+            </a:pPr>
+            <a:r>
+              <a:rPr lang="en-US" sz="800" b="1" dirty="0">
+                <a:solidFill>
+                  <a:srgbClr val="032254"/>
+                </a:solidFill>
+                <a:latin typeface="Aptos" pitchFamily="34" charset="0"/>
+                <a:ea typeface="Aptos" pitchFamily="34" charset="-122"/>
+                <a:cs typeface="Aptos" pitchFamily="34" charset="-120"/>
               </a:rPr>
               <a:t>Customer-owned repo</a:t>
             </a:r>
             <a:pPr indent="0" marL="0">
               <a:spcAft>
-                <a:spcPts val="500"/>
-              </a:spcAft>
-              <a:buNone/>
-            </a:pPr>
-            <a:r>
-              <a:rPr lang="en-US" sz="860" dirty="0">
-                <a:solidFill>
-                  <a:srgbClr val="404040"/>
-                </a:solidFill>
-                <a:latin typeface="Segoe UI" pitchFamily="34" charset="0"/>
-                <a:ea typeface="Segoe UI" pitchFamily="34" charset="-122"/>
-                <a:cs typeface="Segoe UI" pitchFamily="34" charset="-120"/>
+                <a:spcPts val="300"/>
+              </a:spcAft>
+              <a:buNone/>
+            </a:pPr>
+            <a:r>
+              <a:rPr lang="en-US" sz="800" dirty="0">
+                <a:solidFill>
+                  <a:srgbClr val="47494E"/>
+                </a:solidFill>
+                <a:latin typeface="Aptos" pitchFamily="34" charset="0"/>
+                <a:ea typeface="Aptos" pitchFamily="34" charset="-122"/>
+                <a:cs typeface="Aptos" pitchFamily="34" charset="-120"/>
               </a:rPr>
               <a:t> that improves every delivery</a:t>
             </a:r>
-            <a:endParaRPr lang="en-US" sz="860" dirty="0"/>
-          </a:p>
-          <a:p>
-            <a:pPr indent="0" marL="0">
-              <a:spcAft>
-                <a:spcPts val="500"/>
+            <a:endParaRPr lang="en-US" sz="800" dirty="0"/>
+          </a:p>
+          <a:p>
+            <a:pPr indent="0" marL="0">
+              <a:spcAft>
+                <a:spcPts val="300"/>
               </a:spcAft>
               <a:buNone/>
             </a:pPr>
             <a:r>
               <a:rPr lang="en-US" sz="750" i="1" dirty="0">
                 <a:solidFill>
-                  <a:srgbClr val="A6A6A6"/>
-                </a:solidFill>
-                <a:latin typeface="Segoe UI" pitchFamily="34" charset="0"/>
-                <a:ea typeface="Segoe UI" pitchFamily="34" charset="-122"/>
-                <a:cs typeface="Segoe UI" pitchFamily="34" charset="-120"/>
+                  <a:srgbClr val="6B7280"/>
+                </a:solidFill>
+                <a:latin typeface="Aptos" pitchFamily="34" charset="0"/>
+                <a:ea typeface="Aptos" pitchFamily="34" charset="-122"/>
+                <a:cs typeface="Aptos" pitchFamily="34" charset="-120"/>
               </a:rPr>
               <a:t>Capstone + evolve</a:t>
             </a:r>
-            <a:endParaRPr lang="en-US" sz="860" dirty="0"/>
+            <a:endParaRPr lang="en-US" sz="800" dirty="0"/>
           </a:p>
         </p:txBody>
       </p:sp>
       <p:sp>
         <p:nvSpPr>
-          <p:cNvPr id="40" name="Text 38"/>
-          <p:cNvSpPr/>
-          <p:nvPr/>
-        </p:nvSpPr>
-        <p:spPr>
-          <a:xfrm>
-            <a:off x="256032" y="6419088"/>
-            <a:ext cx="11676888" cy="365760"/>
+          <p:cNvPr id="55" name="Text 52"/>
+          <p:cNvSpPr/>
+          <p:nvPr/>
+        </p:nvSpPr>
+        <p:spPr>
+          <a:xfrm>
+            <a:off x="274320" y="6309360"/>
+            <a:ext cx="7772400" cy="420624"/>
           </a:xfrm>
           <a:prstGeom prst="rect">
             <a:avLst/>
@@ -3707,21 +4127,60 @@
           <a:bodyPr wrap="square" lIns="0" tIns="0" rIns="0" bIns="0" rtlCol="0" anchor="ctr"/>
           <a:lstStyle/>
           <a:p>
-            <a:pPr algn="ctr" indent="0" marL="0">
-              <a:buNone/>
-            </a:pPr>
-            <a:r>
-              <a:rPr lang="en-US" sz="1500" b="1" i="1" dirty="0">
-                <a:solidFill>
-                  <a:srgbClr val="1F3864"/>
-                </a:solidFill>
-                <a:latin typeface="Segoe UI" pitchFamily="34" charset="0"/>
-                <a:ea typeface="Segoe UI" pitchFamily="34" charset="-122"/>
-                <a:cs typeface="Segoe UI" pitchFamily="34" charset="-120"/>
+            <a:pPr algn="l" indent="0" marL="0">
+              <a:buNone/>
+            </a:pPr>
+            <a:r>
+              <a:rPr lang="en-US" sz="1350" b="1" i="1" dirty="0">
+                <a:solidFill>
+                  <a:srgbClr val="032254"/>
+                </a:solidFill>
+                <a:latin typeface="Aptos Display" pitchFamily="34" charset="0"/>
+                <a:ea typeface="Aptos Display" pitchFamily="34" charset="-122"/>
+                <a:cs typeface="Aptos Display" pitchFamily="34" charset="-120"/>
               </a:rPr>
               <a:t>“Prove governance in hours. Repeat it across every Fabric tenant.”</a:t>
             </a:r>
-            <a:endParaRPr lang="en-US" sz="1500" dirty="0"/>
+            <a:endParaRPr lang="en-US" sz="1350" dirty="0"/>
+          </a:p>
+        </p:txBody>
+      </p:sp>
+      <p:sp>
+        <p:nvSpPr>
+          <p:cNvPr id="56" name="Text 53"/>
+          <p:cNvSpPr/>
+          <p:nvPr/>
+        </p:nvSpPr>
+        <p:spPr>
+          <a:xfrm>
+            <a:off x="8183880" y="6309360"/>
+            <a:ext cx="3639312" cy="420624"/>
+          </a:xfrm>
+          <a:prstGeom prst="rect">
+            <a:avLst/>
+          </a:prstGeom>
+          <a:noFill/>
+          <a:ln/>
+        </p:spPr>
+        <p:txBody>
+          <a:bodyPr wrap="square" lIns="0" tIns="0" rIns="0" bIns="0" rtlCol="0" anchor="ctr"/>
+          <a:lstStyle/>
+          <a:p>
+            <a:pPr algn="r" indent="0" marL="0">
+              <a:buNone/>
+            </a:pPr>
+            <a:r>
+              <a:rPr lang="en-US" sz="1300" b="1" dirty="0">
+                <a:solidFill>
+                  <a:srgbClr val="1A77E3"/>
+                </a:solidFill>
+                <a:latin typeface="Aptos Display" pitchFamily="34" charset="0"/>
+                <a:ea typeface="Aptos Display" pitchFamily="34" charset="-122"/>
+                <a:cs typeface="Aptos Display" pitchFamily="34" charset="-120"/>
+              </a:rPr>
+              <a:t>Build. Innovate. Scale real value.</a:t>
+            </a:r>
+            <a:endParaRPr lang="en-US" sz="1300" dirty="0"/>
           </a:p>
         </p:txBody>
       </p:sp>

</xml_diff>